<commit_message>
Konuşma notları: yazarlara doğrudan atıflar edilgen dile çevrildi
'Yazarlar ... vurgulamaktadır' gibi ifadeler 'Makalede ... vurgulanmaktadır'
biçimine getirildi (11 yer). PowerPoint not bölmesi Word notlarıyla
yeniden eşitlendi.

Co-Authored-By: Claude Opus 5.5 <noreply@anthropic.com>
Claude-Session: https://claude.ai/code/session_013LLNDYinKcb3EYpgyk92AX
</commit_message>
<xml_diff>
--- a/Sunumlar/Makale_Sunumu_Sigara_Birakma.pptx
+++ b/Sunumlar/Makale_Sunumu_Sigara_Birakma.pptx
@@ -1367,7 +1367,7 @@
           <a:lstStyle/>
           <a:p>
             <a:r>
-              <a:t>Tablo 5'te tedavi yöntemlerine göre bırakma oranları yer almaktadır. Yazarlara göre en yüksek bırakma oranı yüzde 44,0 ile kombine tedavi grubundadır ve kombine tedavi diğer tüm seçeneklerden anlamlı derecede üstündür.</a:t>
+              <a:t>Tablo 5'te tedavi yöntemlerine göre bırakma oranları yer almaktadır. Makalede en yüksek bırakma oranının yüzde 44,0 ile kombine tedavi grubunda olduğu ve kombine tedavinin diğer tüm seçeneklerden anlamlı derecede üstün olduğu bildirilmektedir.</a:t>
             </a:r>
           </a:p>
           <a:p>
@@ -1468,7 +1468,7 @@
           </a:p>
           <a:p>
             <a:r>
-              <a:t>Hanede sigara içen olmaması bırakma olasılığını yaklaşık iki katına, sigaraya bağlı yakınma olmaması 1,6 katına çıkarmaktadır. Yazarlar ayrıca FNBT puanının bırakma başarısının negatif bir öngörücüsü olduğunu bildirmektedir.</a:t>
+              <a:t>Hanede sigara içen olmaması bırakma olasılığını yaklaşık iki katına, sigaraya bağlı yakınma olmaması 1,6 katına çıkarmaktadır. Ayrıca FNBT puanının bırakma başarısının negatif bir öngörücüsü olduğu bildirilmektedir.</a:t>
             </a:r>
           </a:p>
         </p:txBody>
@@ -1645,7 +1645,7 @@
           <a:lstStyle/>
           <a:p>
             <a:r>
-              <a:t>Yazarlar bulgularını literatürle karşılaştırmıştır. Vareniklinin bupropiona üstünlüğü büyük ölçekli meta-analizler ve randomize kontrollü çalışmalarla uyumludur. Bu üstünlüğün, vareniklinin α4β2 nikotinik reseptördeki parsiyel agonist etkisiyle ilişkili olduğu düşünülmektedir.</a:t>
+              <a:t>Makalede bulgular literatürle karşılaştırılmaktadır. Vareniklinin bupropiona üstünlüğü büyük ölçekli meta-analizler ve randomize kontrollü çalışmalarla uyumludur. Bu üstünlüğün, vareniklinin α4β2 nikotinik reseptördeki parsiyel agonist etkisiyle ilişkili olduğu düşünülmektedir.</a:t>
             </a:r>
           </a:p>
           <a:p>
@@ -1741,7 +1741,7 @@
           <a:lstStyle/>
           <a:p>
             <a:r>
-              <a:t>Yazarlar davranışsal desteğin önemini vurgulamaktadır: Daha fazla görüşmeye gelen hastalarda bırakma oranı daha yüksektir.</a:t>
+              <a:t>Makalede davranışsal desteğin önemi vurgulanmaktadır: Daha fazla görüşmeye gelen hastalarda bırakma oranı daha yüksektir.</a:t>
             </a:r>
           </a:p>
           <a:p>
@@ -1751,7 +1751,7 @@
           </a:p>
           <a:p>
             <a:r>
-              <a:t>Hastaların ortalama FNBT puanı, tedavi arayan sigara içicilerinde bildirilen yaklaşık 5 puanla uyumludur ve yüksek puan düşük başarıyla ilişkilidir. Yakınması olmayan hastalarda başarının daha yüksek olması uzun vadeli sağlığı korumaya yönelik içsel motivasyonla açıklanmaktadır. Yazarlar ikinci bir olasılık olarak, kronik hastalığı veya semptomu olan bireylerin sigarayı bir baş etme aracı olarak kullanıyor olabileceğini ve bunun bırakmayı zorlaştırabileceğini belirtmektedir.</a:t>
+              <a:t>Hastaların ortalama FNBT puanı, tedavi arayan sigara içicilerinde bildirilen yaklaşık 5 puanla uyumludur ve yüksek puan düşük başarıyla ilişkilidir. Yakınması olmayan hastalarda başarının daha yüksek olması uzun vadeli sağlığı korumaya yönelik içsel motivasyonla açıklanmaktadır. İkinci bir olasılık olarak, kronik hastalığı veya semptomu olan bireylerin sigarayı bir baş etme aracı olarak kullanıyor olabileceği ve bunun bırakmayı zorlaştırabileceği belirtilmektedir.</a:t>
             </a:r>
           </a:p>
         </p:txBody>
@@ -1837,12 +1837,12 @@
           <a:lstStyle/>
           <a:p>
             <a:r>
-              <a:t>Yazarlar kısıtlılık olarak asistan rotasyonlarının takip sürekliliğini etkileyebileceğini, eksik verilerin telefonla ve hasta beyanıyla tamamlandığını ve vareniklinin piyasadan çekilmesinin ilaç seçimini etkilediğini belirtmektedir.</a:t>
-            </a:r>
-          </a:p>
-          <a:p>
-            <a:r>
-              <a:t>Güçlü yön olarak bu çalışmanın, bildikleri kadarıyla sitizin ile sigara bırakma tedavisini ele alan erişilebilir ilk tez çalışması olduğunu ve birçok tedavi seçeneğini bir arada değerlendirdiğini vurgulamaktadırlar.</a:t>
+              <a:t>Makalede kısıtlılık olarak asistan rotasyonlarının takip sürekliliğini etkileyebileceği, eksik verilerin telefonla ve hasta beyanıyla tamamlandığı ve vareniklinin piyasadan çekilmesinin ilaç seçimini etkilediği belirtilmektedir.</a:t>
+            </a:r>
+          </a:p>
+          <a:p>
+            <a:r>
+              <a:t>Güçlü yön olarak, bu çalışmanın bilinen kadarıyla sitizin ile sigara bırakma tedavisini ele alan erişilebilir ilk tez çalışması olduğu ve birçok tedavi seçeneğini bir arada değerlendirdiği vurgulanmaktadır.</a:t>
             </a:r>
           </a:p>
         </p:txBody>
@@ -1928,12 +1928,12 @@
           <a:lstStyle/>
           <a:p>
             <a:r>
-              <a:t>Yazarların sonucuna göre hastaların yaklaşık üçte biri sigarayı bırakmıştır. Kombine tedavi alanlarda bırakma oranı diğer seçeneklere göre daha yüksektir ve tedaviye uyum arttıkça başarı da artmaktadır.</a:t>
-            </a:r>
-          </a:p>
-          <a:p>
-            <a:r>
-              <a:t>Yazarlar tedavi seanslarında hastaların bırakma motivasyonunu artırmaya yönelik çabaların yoğunlaştırılmasını önermektedir.</a:t>
+              <a:t>Çalışmanın sonucuna göre hastaların yaklaşık üçte biri sigarayı bırakmıştır. Kombine tedavi alanlarda bırakma oranı diğer seçeneklere göre daha yüksektir ve tedaviye uyum arttıkça başarı da artmaktadır.</a:t>
+            </a:r>
+          </a:p>
+          <a:p>
+            <a:r>
+              <a:t>Makalede tedavi seanslarında hastaların bırakma motivasyonunu artırmaya yönelik çabaların yoğunlaştırılması önerilmektedir.</a:t>
             </a:r>
           </a:p>
         </p:txBody>
@@ -2656,7 +2656,7 @@
           <a:lstStyle/>
           <a:p>
             <a:r>
-              <a:t>Yazarların amacı, kombine tedavinin ve yakın takibin sigara bırakma başarısı üzerindeki etkisini değerlendirmek ve bırakmayı etkileyen hasta özelliklerini belirlemektir.</a:t>
+              <a:t>Çalışmanın amacı, kombine tedavinin ve yakın takibin sigara bırakma başarısı üzerindeki etkisini değerlendirmek ve bırakmayı etkileyen hasta özelliklerini belirlemektir.</a:t>
             </a:r>
           </a:p>
         </p:txBody>

</xml_diff>

<commit_message>
Sunum: kullanıcının son düzenlemeleri temel alındı, notlar edilgen dile çevrildi
Kullanıcının olgu slaytını çıkardığı 26 slaytlık sürümü temel alındı;
slayt içeriğine dokunulmadı. Not bölmesindeki yazarlara doğrudan atıflar
edilgen dile çevrildi. Word notlarından olgu bölümü çıkarıldı, başlıklar
1-26 olarak düzenlendi ve 2. slayt notu kullanıcının metniyle eşitlendi.

Co-Authored-By: Claude Opus 5.5 <noreply@anthropic.com>
Claude-Session: https://claude.ai/code/session_013LLNDYinKcb3EYpgyk92AX
</commit_message>
<xml_diff>
--- a/Sunumlar/Makale_Sunumu_Sigara_Birakma.pptx
+++ b/Sunumlar/Makale_Sunumu_Sigara_Birakma.pptx
@@ -5,7 +5,7 @@
     <p:sldMasterId id="2147483648" r:id="rId1"/>
   </p:sldMasterIdLst>
   <p:notesMasterIdLst>
-    <p:notesMasterId r:id="rId29"/>
+    <p:notesMasterId r:id="rId28"/>
   </p:notesMasterIdLst>
   <p:sldIdLst>
     <p:sldId id="256" r:id="rId2"/>
@@ -31,10 +31,9 @@
     <p:sldId id="277" r:id="rId22"/>
     <p:sldId id="278" r:id="rId23"/>
     <p:sldId id="279" r:id="rId24"/>
-    <p:sldId id="280" r:id="rId25"/>
-    <p:sldId id="281" r:id="rId26"/>
-    <p:sldId id="282" r:id="rId27"/>
-    <p:sldId id="283" r:id="rId28"/>
+    <p:sldId id="281" r:id="rId25"/>
+    <p:sldId id="282" r:id="rId26"/>
+    <p:sldId id="283" r:id="rId27"/>
   </p:sldIdLst>
   <p:sldSz cx="12192000" cy="6858000"/>
   <p:notesSz cx="6858000" cy="12192000"/>
@@ -174,7 +173,6 @@
         <p14:section name="Sonuç" id="{D7D5B8D7-35CC-0BDF-FC0E-24C71FE0EBF6}">
           <p14:sldIdLst>
             <p14:sldId id="279"/>
-            <p14:sldId id="280"/>
             <p14:sldId id="281"/>
             <p14:sldId id="282"/>
             <p14:sldId id="283"/>
@@ -194,12 +192,12 @@
   <pc:docChgLst>
     <pc:chgData name="Ahmet Kıran" userId="79d1f92f95b4ea5f" providerId="LiveId" clId="{731B8B29-0491-457A-988D-17AFD8C29442}"/>
     <pc:docChg chg="undo redo custSel delSld modSld modSection">
-      <pc:chgData name="Ahmet Kıran" userId="79d1f92f95b4ea5f" providerId="LiveId" clId="{731B8B29-0491-457A-988D-17AFD8C29442}" dt="2026-10-14T19:04:15.953" v="136" actId="6549"/>
+      <pc:chgData name="Ahmet Kıran" userId="79d1f92f95b4ea5f" providerId="LiveId" clId="{731B8B29-0491-457A-988D-17AFD8C29442}" dt="2026-10-14T22:18:28.756" v="226" actId="6549"/>
       <pc:docMkLst>
         <pc:docMk/>
       </pc:docMkLst>
       <pc:sldChg chg="modSp mod">
-        <pc:chgData name="Ahmet Kıran" userId="79d1f92f95b4ea5f" providerId="LiveId" clId="{731B8B29-0491-457A-988D-17AFD8C29442}" dt="2026-10-14T18:31:35.752" v="134" actId="20577"/>
+        <pc:chgData name="Ahmet Kıran" userId="79d1f92f95b4ea5f" providerId="LiveId" clId="{731B8B29-0491-457A-988D-17AFD8C29442}" dt="2026-10-14T21:46:20.291" v="137" actId="20577"/>
         <pc:sldMkLst>
           <pc:docMk/>
           <pc:sldMk cId="0" sldId="256"/>
@@ -213,7 +211,7 @@
           </ac:spMkLst>
         </pc:spChg>
         <pc:spChg chg="mod">
-          <ac:chgData name="Ahmet Kıran" userId="79d1f92f95b4ea5f" providerId="LiveId" clId="{731B8B29-0491-457A-988D-17AFD8C29442}" dt="2026-10-14T18:03:36.972" v="94" actId="20577"/>
+          <ac:chgData name="Ahmet Kıran" userId="79d1f92f95b4ea5f" providerId="LiveId" clId="{731B8B29-0491-457A-988D-17AFD8C29442}" dt="2026-10-14T21:46:20.291" v="137" actId="20577"/>
           <ac:spMkLst>
             <pc:docMk/>
             <pc:sldMk cId="0" sldId="256"/>
@@ -221,14 +219,14 @@
           </ac:spMkLst>
         </pc:spChg>
       </pc:sldChg>
-      <pc:sldChg chg="delSp modSp mod">
-        <pc:chgData name="Ahmet Kıran" userId="79d1f92f95b4ea5f" providerId="LiveId" clId="{731B8B29-0491-457A-988D-17AFD8C29442}" dt="2026-10-14T18:04:40.524" v="99" actId="478"/>
+      <pc:sldChg chg="delSp modSp mod modNotesTx">
+        <pc:chgData name="Ahmet Kıran" userId="79d1f92f95b4ea5f" providerId="LiveId" clId="{731B8B29-0491-457A-988D-17AFD8C29442}" dt="2026-10-14T22:15:37.093" v="221" actId="20577"/>
         <pc:sldMkLst>
           <pc:docMk/>
           <pc:sldMk cId="0" sldId="257"/>
         </pc:sldMkLst>
         <pc:spChg chg="del">
-          <ac:chgData name="Ahmet Kıran" userId="79d1f92f95b4ea5f" providerId="LiveId" clId="{731B8B29-0491-457A-988D-17AFD8C29442}" dt="2026-10-14T18:04:30.937" v="95" actId="478"/>
+          <ac:chgData name="Ahmet Kıran" userId="79d1f92f95b4ea5f" providerId="LiveId" clId="{731B8B29-0491-457A-988D-17AFD8C29442}" dt="2026-10-14T22:15:12.732" v="153" actId="478"/>
           <ac:spMkLst>
             <pc:docMk/>
             <pc:sldMk cId="0" sldId="257"/>
@@ -236,7 +234,7 @@
           </ac:spMkLst>
         </pc:spChg>
         <pc:spChg chg="del">
-          <ac:chgData name="Ahmet Kıran" userId="79d1f92f95b4ea5f" providerId="LiveId" clId="{731B8B29-0491-457A-988D-17AFD8C29442}" dt="2026-10-14T18:04:34.614" v="97" actId="478"/>
+          <ac:chgData name="Ahmet Kıran" userId="79d1f92f95b4ea5f" providerId="LiveId" clId="{731B8B29-0491-457A-988D-17AFD8C29442}" dt="2026-10-14T22:15:19.318" v="156" actId="478"/>
           <ac:spMkLst>
             <pc:docMk/>
             <pc:sldMk cId="0" sldId="257"/>
@@ -244,7 +242,7 @@
           </ac:spMkLst>
         </pc:spChg>
         <pc:spChg chg="del">
-          <ac:chgData name="Ahmet Kıran" userId="79d1f92f95b4ea5f" providerId="LiveId" clId="{731B8B29-0491-457A-988D-17AFD8C29442}" dt="2026-10-14T18:04:32.992" v="96" actId="478"/>
+          <ac:chgData name="Ahmet Kıran" userId="79d1f92f95b4ea5f" providerId="LiveId" clId="{731B8B29-0491-457A-988D-17AFD8C29442}" dt="2026-10-14T22:15:17.319" v="155" actId="478"/>
           <ac:spMkLst>
             <pc:docMk/>
             <pc:sldMk cId="0" sldId="257"/>
@@ -252,7 +250,7 @@
           </ac:spMkLst>
         </pc:spChg>
         <pc:spChg chg="del mod">
-          <ac:chgData name="Ahmet Kıran" userId="79d1f92f95b4ea5f" providerId="LiveId" clId="{731B8B29-0491-457A-988D-17AFD8C29442}" dt="2026-10-14T18:04:40.524" v="99" actId="478"/>
+          <ac:chgData name="Ahmet Kıran" userId="79d1f92f95b4ea5f" providerId="LiveId" clId="{731B8B29-0491-457A-988D-17AFD8C29442}" dt="2026-10-14T22:15:15.211" v="154" actId="478"/>
           <ac:spMkLst>
             <pc:docMk/>
             <pc:sldMk cId="0" sldId="257"/>
@@ -300,7 +298,7 @@
         </pc:picChg>
       </pc:sldChg>
       <pc:sldChg chg="addSp delSp modSp mod">
-        <pc:chgData name="Ahmet Kıran" userId="79d1f92f95b4ea5f" providerId="LiveId" clId="{731B8B29-0491-457A-988D-17AFD8C29442}" dt="2026-10-14T18:28:10.708" v="126" actId="478"/>
+        <pc:chgData name="Ahmet Kıran" userId="79d1f92f95b4ea5f" providerId="LiveId" clId="{731B8B29-0491-457A-988D-17AFD8C29442}" dt="2026-10-14T22:16:27.902" v="224" actId="1076"/>
         <pc:sldMkLst>
           <pc:docMk/>
           <pc:sldMk cId="0" sldId="259"/>
@@ -327,6 +325,54 @@
             <pc:docMk/>
             <pc:sldMk cId="0" sldId="259"/>
             <ac:spMk id="11" creationId="{00000000-0000-0000-0000-000000000000}"/>
+          </ac:spMkLst>
+        </pc:spChg>
+        <pc:spChg chg="mod">
+          <ac:chgData name="Ahmet Kıran" userId="79d1f92f95b4ea5f" providerId="LiveId" clId="{731B8B29-0491-457A-988D-17AFD8C29442}" dt="2026-10-14T22:16:27.902" v="224" actId="1076"/>
+          <ac:spMkLst>
+            <pc:docMk/>
+            <pc:sldMk cId="0" sldId="259"/>
+            <ac:spMk id="12" creationId="{00000000-0000-0000-0000-000000000000}"/>
+          </ac:spMkLst>
+        </pc:spChg>
+        <pc:spChg chg="mod">
+          <ac:chgData name="Ahmet Kıran" userId="79d1f92f95b4ea5f" providerId="LiveId" clId="{731B8B29-0491-457A-988D-17AFD8C29442}" dt="2026-10-14T22:16:27.902" v="224" actId="1076"/>
+          <ac:spMkLst>
+            <pc:docMk/>
+            <pc:sldMk cId="0" sldId="259"/>
+            <ac:spMk id="13" creationId="{00000000-0000-0000-0000-000000000000}"/>
+          </ac:spMkLst>
+        </pc:spChg>
+        <pc:spChg chg="mod">
+          <ac:chgData name="Ahmet Kıran" userId="79d1f92f95b4ea5f" providerId="LiveId" clId="{731B8B29-0491-457A-988D-17AFD8C29442}" dt="2026-10-14T22:16:27.902" v="224" actId="1076"/>
+          <ac:spMkLst>
+            <pc:docMk/>
+            <pc:sldMk cId="0" sldId="259"/>
+            <ac:spMk id="14" creationId="{00000000-0000-0000-0000-000000000000}"/>
+          </ac:spMkLst>
+        </pc:spChg>
+        <pc:spChg chg="mod">
+          <ac:chgData name="Ahmet Kıran" userId="79d1f92f95b4ea5f" providerId="LiveId" clId="{731B8B29-0491-457A-988D-17AFD8C29442}" dt="2026-10-14T22:16:27.902" v="224" actId="1076"/>
+          <ac:spMkLst>
+            <pc:docMk/>
+            <pc:sldMk cId="0" sldId="259"/>
+            <ac:spMk id="15" creationId="{00000000-0000-0000-0000-000000000000}"/>
+          </ac:spMkLst>
+        </pc:spChg>
+        <pc:spChg chg="mod">
+          <ac:chgData name="Ahmet Kıran" userId="79d1f92f95b4ea5f" providerId="LiveId" clId="{731B8B29-0491-457A-988D-17AFD8C29442}" dt="2026-10-14T22:16:27.902" v="224" actId="1076"/>
+          <ac:spMkLst>
+            <pc:docMk/>
+            <pc:sldMk cId="0" sldId="259"/>
+            <ac:spMk id="16" creationId="{00000000-0000-0000-0000-000000000000}"/>
+          </ac:spMkLst>
+        </pc:spChg>
+        <pc:spChg chg="mod">
+          <ac:chgData name="Ahmet Kıran" userId="79d1f92f95b4ea5f" providerId="LiveId" clId="{731B8B29-0491-457A-988D-17AFD8C29442}" dt="2026-10-14T22:16:27.902" v="224" actId="1076"/>
+          <ac:spMkLst>
+            <pc:docMk/>
+            <pc:sldMk cId="0" sldId="259"/>
+            <ac:spMk id="17" creationId="{00000000-0000-0000-0000-000000000000}"/>
           </ac:spMkLst>
         </pc:spChg>
       </pc:sldChg>
@@ -365,6 +411,50 @@
             <pc:docMk/>
             <pc:sldMk cId="0" sldId="274"/>
             <ac:spMk id="9" creationId="{00000000-0000-0000-0000-000000000000}"/>
+          </ac:spMkLst>
+        </pc:spChg>
+      </pc:sldChg>
+      <pc:sldChg chg="modSp mod">
+        <pc:chgData name="Ahmet Kıran" userId="79d1f92f95b4ea5f" providerId="LiveId" clId="{731B8B29-0491-457A-988D-17AFD8C29442}" dt="2026-10-14T22:09:47.944" v="138" actId="1036"/>
+        <pc:sldMkLst>
+          <pc:docMk/>
+          <pc:sldMk cId="0" sldId="277"/>
+        </pc:sldMkLst>
+        <pc:spChg chg="mod">
+          <ac:chgData name="Ahmet Kıran" userId="79d1f92f95b4ea5f" providerId="LiveId" clId="{731B8B29-0491-457A-988D-17AFD8C29442}" dt="2026-10-14T22:09:47.944" v="138" actId="1036"/>
+          <ac:spMkLst>
+            <pc:docMk/>
+            <pc:sldMk cId="0" sldId="277"/>
+            <ac:spMk id="20" creationId="{00000000-0000-0000-0000-000000000000}"/>
+          </ac:spMkLst>
+        </pc:spChg>
+      </pc:sldChg>
+      <pc:sldChg chg="del">
+        <pc:chgData name="Ahmet Kıran" userId="79d1f92f95b4ea5f" providerId="LiveId" clId="{731B8B29-0491-457A-988D-17AFD8C29442}" dt="2026-10-14T22:11:10.644" v="139" actId="2696"/>
+        <pc:sldMkLst>
+          <pc:docMk/>
+          <pc:sldMk cId="0" sldId="280"/>
+        </pc:sldMkLst>
+      </pc:sldChg>
+      <pc:sldChg chg="modNotesTx">
+        <pc:chgData name="Ahmet Kıran" userId="79d1f92f95b4ea5f" providerId="LiveId" clId="{731B8B29-0491-457A-988D-17AFD8C29442}" dt="2026-10-14T22:18:28.756" v="226" actId="6549"/>
+        <pc:sldMkLst>
+          <pc:docMk/>
+          <pc:sldMk cId="0" sldId="282"/>
+        </pc:sldMkLst>
+      </pc:sldChg>
+      <pc:sldChg chg="modSp mod modNotesTx">
+        <pc:chgData name="Ahmet Kıran" userId="79d1f92f95b4ea5f" providerId="LiveId" clId="{731B8B29-0491-457A-988D-17AFD8C29442}" dt="2026-10-14T22:18:13.900" v="225" actId="6549"/>
+        <pc:sldMkLst>
+          <pc:docMk/>
+          <pc:sldMk cId="0" sldId="283"/>
+        </pc:sldMkLst>
+        <pc:spChg chg="mod">
+          <ac:chgData name="Ahmet Kıran" userId="79d1f92f95b4ea5f" providerId="LiveId" clId="{731B8B29-0491-457A-988D-17AFD8C29442}" dt="2026-10-14T22:11:28.430" v="140" actId="6549"/>
+          <ac:spMkLst>
+            <pc:docMk/>
+            <pc:sldMk cId="0" sldId="283"/>
+            <ac:spMk id="4" creationId="{00000000-0000-0000-0000-000000000000}"/>
           </ac:spMkLst>
         </pc:spChg>
       </pc:sldChg>
@@ -1554,12 +1644,12 @@
           <a:lstStyle/>
           <a:p>
             <a:r>
-              <a:t>Sunum 27 slayttan oluşmakta ve yaklaşık yarım saat sürecektir.</a:t>
-            </a:r>
-          </a:p>
-          <a:p>
-            <a:r>
-              <a:t>Makalenin künyesi ve giriş bölümüyle başlayıp gereç ve yöntemi aktaracağım. Bulgular bölümünde makaledeki altı tabloyu özgün halleriyle göstereceğim. Ardından hocalarımızın tartışma ve sonuçlarını aktaracak, son olarak kısa bir olgu üzerinden görüşlerinizi alacağım.</a:t>
+              <a:t>Sunum 26 slayttan oluşmakta ve yaklaşık yirmi dk sürecektir.</a:t>
+            </a:r>
+          </a:p>
+          <a:p>
+            <a:r>
+              <a:t>Makalenin künyesi ve giriş bölümüyle başlayıp gereç ve yöntemi aktaracağım. Bulgular bölümünde makaledeki tabloyu özgün halleriyle göstereceğim. Ardından hocalarımızın tartışma ve sonuçlarını aktaracağım.</a:t>
             </a:r>
           </a:p>
         </p:txBody>
@@ -2019,22 +2109,12 @@
           <a:lstStyle/>
           <a:p>
             <a:r>
-              <a:t>Bulguları pratiğe aktarmak için kısa bir olgu üzerinden görüşlerinizi almak istiyorum.</a:t>
-            </a:r>
-          </a:p>
-          <a:p>
-            <a:r>
-              <a:t>52 yaşında erkek hasta; günde 25 sigara içiyor, 30 paket-yıl öyküsü var, FNBT puanı 8. Daha önce bupropion ile denemiş ve başaramamış. Eşi de sigara içiyor.</a:t>
-            </a:r>
-          </a:p>
-          <a:p>
-            <a:r>
-              <a:t>Bu hastada hangi tedaviyi seçerdiniz? Takibi nasıl planlardınız? Eşini sürece nasıl dahil ederdiniz?</a:t>
-            </a:r>
-          </a:p>
-          <a:p>
-            <a:r>
-              <a:t>[Burada 2–3 dakika görüş alın. Makalenin bulgularına göre tartışmayı şu noktalara yönlendirebilirsiniz: Kombine tedavi veya vareniklin/sitizin temelli tedavi, sık kontrol görüşmeleri ve eşe de bırakma danışmanlığı önerilmesi.]</a:t>
+              <a:t>Sunumu beş mesajla özetlemek istiyorum.</a:t>
+            </a:r>
+          </a:p>
+          <a:p>
+            <a:r>
+              <a:t>Hastaların yaklaşık üçte biri sigarayı bırakmıştır. Kombine tedavide başarı daha yüksektir. Bupropion monoterapisi en düşük başarının görüldüğü seçenektir. Hanede sigara içen olması başarıyı azaltmaktadır. Sık takip başarıyla ilişkilidir.</a:t>
             </a:r>
           </a:p>
         </p:txBody>
@@ -2119,14 +2199,7 @@
           <a:bodyPr/>
           <a:lstStyle/>
           <a:p>
-            <a:r>
-              <a:t>Sunumu beş mesajla özetlemek istiyorum.</a:t>
-            </a:r>
-          </a:p>
-          <a:p>
-            <a:r>
-              <a:t>Hastaların yaklaşık üçte biri sigarayı bırakmıştır. Kombine tedavide başarı daha yüksektir. Bupropion monoterapisi en düşük başarının görüldüğü seçenektir. Hanede sigara içen olması başarıyı azaltmaktadır. Sık takip başarıyla ilişkilidir.</a:t>
-            </a:r>
+            <a:endParaRPr dirty="0"/>
           </a:p>
         </p:txBody>
       </p:sp>
@@ -2210,9 +2283,7 @@
           <a:bodyPr/>
           <a:lstStyle/>
           <a:p>
-            <a:r>
-              <a:t>Kaynaklar Vancouver stiline uygun olarak, kullanım sırasıyla listelenmiştir. Birinci kaynak sunulan makalenin kendisidir; diğerleri makalenin atıf yaptığı çalışmalardır.</a:t>
-            </a:r>
+            <a:endParaRPr dirty="0"/>
           </a:p>
         </p:txBody>
       </p:sp>
@@ -2234,92 +2305,6 @@
             <a:fld id="{F7021451-1387-4CA6-816F-3879F97B5CBC}" type="slidenum">
               <a:rPr lang="en-US"/>
               <a:t>26</a:t>
-            </a:fld>
-            <a:endParaRPr lang="en-US"/>
-          </a:p>
-        </p:txBody>
-      </p:sp>
-    </p:spTree>
-    <p:extLst>
-      <p:ext uri="{BB962C8B-B14F-4D97-AF65-F5344CB8AC3E}">
-        <p14:creationId xmlns:p14="http://schemas.microsoft.com/office/powerpoint/2010/main" val="1024086991"/>
-      </p:ext>
-    </p:extLst>
-  </p:cSld>
-  <p:clrMapOvr>
-    <a:masterClrMapping/>
-  </p:clrMapOvr>
-</p:notes>
-</file>
-
-<file path=ppt/notesSlides/notesSlide27.xml><?xml version="1.0" encoding="utf-8"?>
-<p:notes xmlns:a="http://schemas.openxmlformats.org/drawingml/2006/main" xmlns:r="http://schemas.openxmlformats.org/officeDocument/2006/relationships" xmlns:p="http://schemas.openxmlformats.org/presentationml/2006/main">
-  <p:cSld>
-    <p:spTree>
-      <p:nvGrpSpPr>
-        <p:cNvPr id="1" name=""/>
-        <p:cNvGrpSpPr/>
-        <p:nvPr/>
-      </p:nvGrpSpPr>
-      <p:grpSpPr>
-        <a:xfrm>
-          <a:off x="0" y="0"/>
-          <a:ext cx="0" cy="0"/>
-          <a:chOff x="0" y="0"/>
-          <a:chExt cx="0" cy="0"/>
-        </a:xfrm>
-      </p:grpSpPr>
-      <p:sp>
-        <p:nvSpPr>
-          <p:cNvPr id="2" name="Slide Image Placeholder 1"/>
-          <p:cNvSpPr>
-            <a:spLocks noGrp="1" noRot="1" noChangeAspect="1"/>
-          </p:cNvSpPr>
-          <p:nvPr>
-            <p:ph type="sldImg"/>
-          </p:nvPr>
-        </p:nvSpPr>
-        <p:spPr/>
-      </p:sp>
-      <p:sp>
-        <p:nvSpPr>
-          <p:cNvPr id="3" name="Notes Placeholder 2"/>
-          <p:cNvSpPr>
-            <a:spLocks noGrp="1"/>
-          </p:cNvSpPr>
-          <p:nvPr>
-            <p:ph type="body" idx="1"/>
-          </p:nvPr>
-        </p:nvSpPr>
-        <p:spPr/>
-        <p:txBody>
-          <a:bodyPr/>
-          <a:lstStyle/>
-          <a:p>
-            <a:r>
-              <a:t>İlginiz ve katkılarınız için teşekkür ederim. Sorularınızı ve görüşlerinizi almaktan memnuniyet duyarım.</a:t>
-            </a:r>
-          </a:p>
-        </p:txBody>
-      </p:sp>
-      <p:sp>
-        <p:nvSpPr>
-          <p:cNvPr id="4" name="Slide Number Placeholder 3"/>
-          <p:cNvSpPr>
-            <a:spLocks noGrp="1"/>
-          </p:cNvSpPr>
-          <p:nvPr>
-            <p:ph type="sldNum" sz="quarter" idx="10"/>
-          </p:nvPr>
-        </p:nvSpPr>
-        <p:spPr/>
-        <p:txBody>
-          <a:bodyPr/>
-          <a:lstStyle/>
-          <a:p>
-            <a:fld id="{F7021451-1387-4CA6-816F-3879F97B5CBC}" type="slidenum">
-              <a:rPr lang="en-US"/>
-              <a:t>27</a:t>
             </a:fld>
             <a:endParaRPr lang="en-US"/>
           </a:p>
@@ -2383,12 +2368,226 @@
           <a:lstStyle/>
           <a:p>
             <a:r>
-              <a:t>Solda makalenin ilk sayfasını görüyorsunuz. Makale Türkiye Aile Hekimleri Uzmanlık Derneği'nin yayın organı olan Turkish Journal of Family Practice'te 2026 yılında yayımlanmıştır.</a:t>
-            </a:r>
-          </a:p>
-          <a:p>
-            <a:r>
-              <a:t>Çalışma retrospektif, kesitsel bir araştırmadır. Veriler Samsun Eğitim ve Araştırma Hastanesi Sigara Bırakma Polikliniği'nden elde edilmiştir.</a:t>
+              <a:rPr dirty="0"/>
+              <a:t>Solda </a:t>
+            </a:r>
+            <a:r>
+              <a:rPr dirty="0" err="1"/>
+              <a:t>makalenin</a:t>
+            </a:r>
+            <a:r>
+              <a:rPr dirty="0"/>
+              <a:t> ilk </a:t>
+            </a:r>
+            <a:r>
+              <a:rPr dirty="0" err="1"/>
+              <a:t>sayfasını</a:t>
+            </a:r>
+            <a:r>
+              <a:rPr dirty="0"/>
+              <a:t> </a:t>
+            </a:r>
+            <a:r>
+              <a:rPr dirty="0" err="1"/>
+              <a:t>görüyorsunuz</a:t>
+            </a:r>
+            <a:r>
+              <a:rPr dirty="0"/>
+              <a:t>. Makale Türkiye Aile </a:t>
+            </a:r>
+            <a:r>
+              <a:rPr dirty="0" err="1"/>
+              <a:t>Hekimleri</a:t>
+            </a:r>
+            <a:r>
+              <a:rPr dirty="0"/>
+              <a:t> </a:t>
+            </a:r>
+            <a:r>
+              <a:rPr dirty="0" err="1"/>
+              <a:t>Uzmanlık</a:t>
+            </a:r>
+            <a:r>
+              <a:rPr dirty="0"/>
+              <a:t> </a:t>
+            </a:r>
+            <a:r>
+              <a:rPr dirty="0" err="1"/>
+              <a:t>Derneği'nin</a:t>
+            </a:r>
+            <a:r>
+              <a:rPr dirty="0"/>
+              <a:t> </a:t>
+            </a:r>
+            <a:r>
+              <a:rPr dirty="0" err="1"/>
+              <a:t>yayın</a:t>
+            </a:r>
+            <a:r>
+              <a:rPr dirty="0"/>
+              <a:t> </a:t>
+            </a:r>
+            <a:r>
+              <a:rPr dirty="0" err="1"/>
+              <a:t>organı</a:t>
+            </a:r>
+            <a:r>
+              <a:rPr dirty="0"/>
+              <a:t> </a:t>
+            </a:r>
+            <a:r>
+              <a:rPr dirty="0" err="1"/>
+              <a:t>olan</a:t>
+            </a:r>
+            <a:r>
+              <a:rPr dirty="0"/>
+              <a:t> Turkish Journal of Family </a:t>
+            </a:r>
+            <a:r>
+              <a:rPr dirty="0" err="1"/>
+              <a:t>Practice'te</a:t>
+            </a:r>
+            <a:r>
+              <a:rPr dirty="0"/>
+              <a:t> 2026 </a:t>
+            </a:r>
+            <a:r>
+              <a:rPr dirty="0" err="1"/>
+              <a:t>yılında</a:t>
+            </a:r>
+            <a:r>
+              <a:rPr dirty="0"/>
+              <a:t> </a:t>
+            </a:r>
+            <a:r>
+              <a:rPr dirty="0" err="1"/>
+              <a:t>yayımlanmıştır</a:t>
+            </a:r>
+            <a:r>
+              <a:rPr dirty="0"/>
+              <a:t>.</a:t>
+            </a:r>
+          </a:p>
+          <a:p>
+            <a:r>
+              <a:rPr dirty="0" err="1"/>
+              <a:t>Çalışma</a:t>
+            </a:r>
+            <a:r>
+              <a:rPr dirty="0"/>
+              <a:t> </a:t>
+            </a:r>
+            <a:r>
+              <a:rPr dirty="0" err="1"/>
+              <a:t>retrospektif</a:t>
+            </a:r>
+            <a:r>
+              <a:rPr dirty="0"/>
+              <a:t>, </a:t>
+            </a:r>
+            <a:r>
+              <a:rPr dirty="0" err="1"/>
+              <a:t>kesitsel</a:t>
+            </a:r>
+            <a:r>
+              <a:rPr dirty="0"/>
+              <a:t> </a:t>
+            </a:r>
+            <a:r>
+              <a:rPr dirty="0" err="1"/>
+              <a:t>bir</a:t>
+            </a:r>
+            <a:r>
+              <a:rPr dirty="0"/>
+              <a:t> </a:t>
+            </a:r>
+            <a:r>
+              <a:rPr dirty="0" err="1"/>
+              <a:t>araştırmadır</a:t>
+            </a:r>
+            <a:r>
+              <a:rPr dirty="0"/>
+              <a:t>. </a:t>
+            </a:r>
+            <a:r>
+              <a:rPr dirty="0" err="1"/>
+              <a:t>Veriler</a:t>
+            </a:r>
+            <a:r>
+              <a:rPr dirty="0"/>
+              <a:t> Samsun </a:t>
+            </a:r>
+            <a:r>
+              <a:rPr dirty="0" err="1"/>
+              <a:t>Eğitim</a:t>
+            </a:r>
+            <a:r>
+              <a:rPr dirty="0"/>
+              <a:t> </a:t>
+            </a:r>
+            <a:r>
+              <a:rPr dirty="0" err="1"/>
+              <a:t>ve</a:t>
+            </a:r>
+            <a:r>
+              <a:rPr dirty="0"/>
+              <a:t> </a:t>
+            </a:r>
+            <a:r>
+              <a:rPr dirty="0" err="1"/>
+              <a:t>Araştırma</a:t>
+            </a:r>
+            <a:r>
+              <a:rPr dirty="0"/>
+              <a:t> </a:t>
+            </a:r>
+            <a:r>
+              <a:rPr dirty="0" err="1"/>
+              <a:t>Hastanesi</a:t>
+            </a:r>
+            <a:r>
+              <a:rPr dirty="0"/>
+              <a:t> </a:t>
+            </a:r>
+            <a:r>
+              <a:rPr dirty="0" err="1"/>
+              <a:t>Sigara</a:t>
+            </a:r>
+            <a:r>
+              <a:rPr dirty="0"/>
+              <a:t> </a:t>
+            </a:r>
+            <a:r>
+              <a:rPr dirty="0" err="1"/>
+              <a:t>Bırakma</a:t>
+            </a:r>
+            <a:r>
+              <a:rPr dirty="0"/>
+              <a:t> </a:t>
+            </a:r>
+            <a:r>
+              <a:rPr dirty="0" err="1"/>
+              <a:t>Polikliniği'nden</a:t>
+            </a:r>
+            <a:r>
+              <a:rPr dirty="0"/>
+              <a:t> </a:t>
+            </a:r>
+            <a:r>
+              <a:rPr dirty="0" err="1"/>
+              <a:t>elde</a:t>
+            </a:r>
+            <a:r>
+              <a:rPr dirty="0"/>
+              <a:t> </a:t>
+            </a:r>
+            <a:r>
+              <a:rPr dirty="0" err="1"/>
+              <a:t>edilmiştir</a:t>
+            </a:r>
+            <a:r>
+              <a:rPr dirty="0"/>
+              <a:t>.</a:t>
             </a:r>
           </a:p>
         </p:txBody>
@@ -3127,7 +3326,7 @@
           </a:prstGeom>
           <a:extLst>
             <a:ext uri="{C572A759-6A51-4108-AA02-DFA0A04FC94B}">
-              <ma14:wrappingTextBoxFlag xmlns:ma14="http://schemas.microsoft.com/office/mac/drawingml/2011/main" xmlns="" val="0"/>
+              <ma14:wrappingTextBoxFlag xmlns="" xmlns:ma14="http://schemas.microsoft.com/office/mac/drawingml/2011/main" val="0"/>
             </a:ext>
           </a:extLst>
         </p:spPr>
@@ -3246,7 +3445,7 @@
           </a:prstGeom>
           <a:extLst>
             <a:ext uri="{C572A759-6A51-4108-AA02-DFA0A04FC94B}">
-              <ma14:wrappingTextBoxFlag xmlns:ma14="http://schemas.microsoft.com/office/mac/drawingml/2011/main" xmlns="" val="0"/>
+              <ma14:wrappingTextBoxFlag xmlns="" xmlns:ma14="http://schemas.microsoft.com/office/mac/drawingml/2011/main" val="0"/>
             </a:ext>
           </a:extLst>
         </p:spPr>
@@ -3365,7 +3564,7 @@
           </a:prstGeom>
           <a:extLst>
             <a:ext uri="{C572A759-6A51-4108-AA02-DFA0A04FC94B}">
-              <ma14:wrappingTextBoxFlag xmlns:ma14="http://schemas.microsoft.com/office/mac/drawingml/2011/main" xmlns="" val="0"/>
+              <ma14:wrappingTextBoxFlag xmlns="" xmlns:ma14="http://schemas.microsoft.com/office/mac/drawingml/2011/main" val="0"/>
             </a:ext>
           </a:extLst>
         </p:spPr>
@@ -3440,7 +3639,7 @@
           </a:prstGeom>
           <a:extLst>
             <a:ext uri="{C572A759-6A51-4108-AA02-DFA0A04FC94B}">
-              <ma14:wrappingTextBoxFlag xmlns:ma14="http://schemas.microsoft.com/office/mac/drawingml/2011/main" xmlns="" val="0"/>
+              <ma14:wrappingTextBoxFlag xmlns="" xmlns:ma14="http://schemas.microsoft.com/office/mac/drawingml/2011/main" val="0"/>
             </a:ext>
           </a:extLst>
         </p:spPr>
@@ -3932,7 +4131,7 @@
                   <a:schemeClr val="bg2"/>
                 </a:solidFill>
               </a:rPr>
-              <a:t>	Danışman	:Prof. Dr. Onur ÖZTÜRK</a:t>
+              <a:t>	Danışman	: Prof. Dr. Onur ÖZTÜRK</a:t>
             </a:r>
             <a:endParaRPr lang="en-US" sz="2000" dirty="0"/>
           </a:p>
@@ -3958,7 +4157,7 @@
           </a:prstGeom>
           <a:extLst>
             <a:ext uri="{C572A759-6A51-4108-AA02-DFA0A04FC94B}">
-              <ma14:wrappingTextBoxFlag xmlns:ma14="http://schemas.microsoft.com/office/mac/drawingml/2011/main" xmlns="" val="0"/>
+              <ma14:wrappingTextBoxFlag xmlns="" xmlns:ma14="http://schemas.microsoft.com/office/mac/drawingml/2011/main" val="0"/>
             </a:ext>
           </a:extLst>
         </p:spPr>
@@ -5049,7 +5248,7 @@
           </a:prstGeom>
           <a:extLst>
             <a:ext uri="{C572A759-6A51-4108-AA02-DFA0A04FC94B}">
-              <ma14:wrappingTextBoxFlag xmlns:ma14="http://schemas.microsoft.com/office/mac/drawingml/2011/main" xmlns="" val="0"/>
+              <ma14:wrappingTextBoxFlag xmlns="" xmlns:ma14="http://schemas.microsoft.com/office/mac/drawingml/2011/main" val="0"/>
             </a:ext>
           </a:extLst>
         </p:spPr>
@@ -5789,7 +5988,7 @@
           </a:prstGeom>
           <a:extLst>
             <a:ext uri="{C572A759-6A51-4108-AA02-DFA0A04FC94B}">
-              <ma14:wrappingTextBoxFlag xmlns:ma14="http://schemas.microsoft.com/office/mac/drawingml/2011/main" xmlns="" val="0"/>
+              <ma14:wrappingTextBoxFlag xmlns="" xmlns:ma14="http://schemas.microsoft.com/office/mac/drawingml/2011/main" val="0"/>
             </a:ext>
           </a:extLst>
         </p:spPr>
@@ -6535,7 +6734,7 @@
           </a:prstGeom>
           <a:extLst>
             <a:ext uri="{C572A759-6A51-4108-AA02-DFA0A04FC94B}">
-              <ma14:wrappingTextBoxFlag xmlns:ma14="http://schemas.microsoft.com/office/mac/drawingml/2011/main" xmlns="" val="0"/>
+              <ma14:wrappingTextBoxFlag xmlns="" xmlns:ma14="http://schemas.microsoft.com/office/mac/drawingml/2011/main" val="0"/>
             </a:ext>
           </a:extLst>
         </p:spPr>
@@ -6900,7 +7099,7 @@
           </a:prstGeom>
           <a:extLst>
             <a:ext uri="{C572A759-6A51-4108-AA02-DFA0A04FC94B}">
-              <ma14:wrappingTextBoxFlag xmlns:ma14="http://schemas.microsoft.com/office/mac/drawingml/2011/main" xmlns="" val="0"/>
+              <ma14:wrappingTextBoxFlag xmlns="" xmlns:ma14="http://schemas.microsoft.com/office/mac/drawingml/2011/main" val="0"/>
             </a:ext>
           </a:extLst>
         </p:spPr>
@@ -7175,7 +7374,7 @@
           </a:prstGeom>
           <a:extLst>
             <a:ext uri="{C572A759-6A51-4108-AA02-DFA0A04FC94B}">
-              <ma14:wrappingTextBoxFlag xmlns:ma14="http://schemas.microsoft.com/office/mac/drawingml/2011/main" xmlns="" val="0"/>
+              <ma14:wrappingTextBoxFlag xmlns="" xmlns:ma14="http://schemas.microsoft.com/office/mac/drawingml/2011/main" val="0"/>
             </a:ext>
           </a:extLst>
         </p:spPr>
@@ -7481,7 +7680,7 @@
           </a:prstGeom>
           <a:extLst>
             <a:ext uri="{C572A759-6A51-4108-AA02-DFA0A04FC94B}">
-              <ma14:wrappingTextBoxFlag xmlns:ma14="http://schemas.microsoft.com/office/mac/drawingml/2011/main" xmlns="" val="0"/>
+              <ma14:wrappingTextBoxFlag xmlns="" xmlns:ma14="http://schemas.microsoft.com/office/mac/drawingml/2011/main" val="0"/>
             </a:ext>
           </a:extLst>
         </p:spPr>
@@ -7784,7 +7983,7 @@
           </a:prstGeom>
           <a:extLst>
             <a:ext uri="{C572A759-6A51-4108-AA02-DFA0A04FC94B}">
-              <ma14:wrappingTextBoxFlag xmlns:ma14="http://schemas.microsoft.com/office/mac/drawingml/2011/main" xmlns="" val="0"/>
+              <ma14:wrappingTextBoxFlag xmlns="" xmlns:ma14="http://schemas.microsoft.com/office/mac/drawingml/2011/main" val="0"/>
             </a:ext>
           </a:extLst>
         </p:spPr>
@@ -8252,7 +8451,7 @@
           </a:prstGeom>
           <a:extLst>
             <a:ext uri="{C572A759-6A51-4108-AA02-DFA0A04FC94B}">
-              <ma14:wrappingTextBoxFlag xmlns:ma14="http://schemas.microsoft.com/office/mac/drawingml/2011/main" xmlns="" val="0"/>
+              <ma14:wrappingTextBoxFlag xmlns="" xmlns:ma14="http://schemas.microsoft.com/office/mac/drawingml/2011/main" val="0"/>
             </a:ext>
           </a:extLst>
         </p:spPr>
@@ -8368,7 +8567,10 @@
         </p:spPr>
         <p:txBody>
           <a:bodyPr/>
-          <a:p/>
+          <a:lstStyle/>
+          <a:p>
+            <a:endParaRPr/>
+          </a:p>
         </p:txBody>
       </p:sp>
       <p:pic>
@@ -8423,7 +8625,10 @@
         </p:spPr>
         <p:txBody>
           <a:bodyPr/>
-          <a:p/>
+          <a:lstStyle/>
+          <a:p>
+            <a:endParaRPr/>
+          </a:p>
         </p:txBody>
       </p:sp>
       <p:sp>
@@ -8504,7 +8709,10 @@
         </p:spPr>
         <p:txBody>
           <a:bodyPr/>
-          <a:p/>
+          <a:lstStyle/>
+          <a:p>
+            <a:endParaRPr/>
+          </a:p>
         </p:txBody>
       </p:sp>
       <p:sp>
@@ -8585,7 +8793,10 @@
         </p:spPr>
         <p:txBody>
           <a:bodyPr/>
-          <a:p/>
+          <a:lstStyle/>
+          <a:p>
+            <a:endParaRPr/>
+          </a:p>
         </p:txBody>
       </p:sp>
       <p:sp>
@@ -8694,7 +8905,7 @@
           </a:prstGeom>
           <a:extLst>
             <a:ext uri="{C572A759-6A51-4108-AA02-DFA0A04FC94B}">
-              <ma14:wrappingTextBoxFlag xmlns:ma14="http://schemas.microsoft.com/office/mac/drawingml/2011/main" xmlns="" val="0"/>
+              <ma14:wrappingTextBoxFlag xmlns="" xmlns:ma14="http://schemas.microsoft.com/office/mac/drawingml/2011/main" val="0"/>
             </a:ext>
           </a:extLst>
         </p:spPr>
@@ -9045,7 +9256,7 @@
           </a:prstGeom>
           <a:extLst>
             <a:ext uri="{C572A759-6A51-4108-AA02-DFA0A04FC94B}">
-              <ma14:wrappingTextBoxFlag xmlns:ma14="http://schemas.microsoft.com/office/mac/drawingml/2011/main" xmlns="" val="0"/>
+              <ma14:wrappingTextBoxFlag xmlns="" xmlns:ma14="http://schemas.microsoft.com/office/mac/drawingml/2011/main" val="0"/>
             </a:ext>
           </a:extLst>
         </p:spPr>
@@ -9163,7 +9374,10 @@
         </p:spPr>
         <p:txBody>
           <a:bodyPr/>
-          <a:p/>
+          <a:lstStyle/>
+          <a:p>
+            <a:endParaRPr/>
+          </a:p>
         </p:txBody>
       </p:sp>
       <p:sp>
@@ -9192,7 +9406,10 @@
         </p:spPr>
         <p:txBody>
           <a:bodyPr/>
-          <a:p/>
+          <a:lstStyle/>
+          <a:p>
+            <a:endParaRPr/>
+          </a:p>
         </p:txBody>
       </p:sp>
       <p:sp>
@@ -9295,7 +9512,10 @@
         </p:spPr>
         <p:txBody>
           <a:bodyPr/>
-          <a:p/>
+          <a:lstStyle/>
+          <a:p>
+            <a:endParaRPr/>
+          </a:p>
         </p:txBody>
       </p:sp>
       <p:sp>
@@ -9324,7 +9544,10 @@
         </p:spPr>
         <p:txBody>
           <a:bodyPr/>
-          <a:p/>
+          <a:lstStyle/>
+          <a:p>
+            <a:endParaRPr/>
+          </a:p>
         </p:txBody>
       </p:sp>
       <p:sp>
@@ -9427,7 +9650,10 @@
         </p:spPr>
         <p:txBody>
           <a:bodyPr/>
-          <a:p/>
+          <a:lstStyle/>
+          <a:p>
+            <a:endParaRPr/>
+          </a:p>
         </p:txBody>
       </p:sp>
       <p:sp>
@@ -9456,7 +9682,10 @@
         </p:spPr>
         <p:txBody>
           <a:bodyPr/>
-          <a:p/>
+          <a:lstStyle/>
+          <a:p>
+            <a:endParaRPr/>
+          </a:p>
         </p:txBody>
       </p:sp>
       <p:sp>
@@ -9559,7 +9788,10 @@
         </p:spPr>
         <p:txBody>
           <a:bodyPr/>
-          <a:p/>
+          <a:lstStyle/>
+          <a:p>
+            <a:endParaRPr/>
+          </a:p>
         </p:txBody>
       </p:sp>
       <p:sp>
@@ -9588,7 +9820,10 @@
         </p:spPr>
         <p:txBody>
           <a:bodyPr/>
-          <a:p/>
+          <a:lstStyle/>
+          <a:p>
+            <a:endParaRPr/>
+          </a:p>
         </p:txBody>
       </p:sp>
       <p:sp>
@@ -9691,7 +9926,10 @@
         </p:spPr>
         <p:txBody>
           <a:bodyPr/>
-          <a:p/>
+          <a:lstStyle/>
+          <a:p>
+            <a:endParaRPr/>
+          </a:p>
         </p:txBody>
       </p:sp>
       <p:sp>
@@ -9720,7 +9958,10 @@
         </p:spPr>
         <p:txBody>
           <a:bodyPr/>
-          <a:p/>
+          <a:lstStyle/>
+          <a:p>
+            <a:endParaRPr/>
+          </a:p>
         </p:txBody>
       </p:sp>
       <p:sp>
@@ -9815,7 +10056,7 @@
           </a:prstGeom>
           <a:extLst>
             <a:ext uri="{C572A759-6A51-4108-AA02-DFA0A04FC94B}">
-              <ma14:wrappingTextBoxFlag xmlns:ma14="http://schemas.microsoft.com/office/mac/drawingml/2011/main" xmlns="" val="0"/>
+              <ma14:wrappingTextBoxFlag xmlns="" xmlns:ma14="http://schemas.microsoft.com/office/mac/drawingml/2011/main" val="0"/>
             </a:ext>
           </a:extLst>
         </p:spPr>
@@ -9837,138 +10078,6 @@
               <a:t>2</a:t>
             </a:fld>
             <a:endParaRPr lang="en-US"/>
-          </a:p>
-        </p:txBody>
-      </p:sp>
-      <p:sp>
-        <p:nvSpPr>
-          <p:cNvPr id="24" name="Kart"/>
-          <p:cNvSpPr/>
-          <p:nvPr/>
-        </p:nvSpPr>
-        <p:spPr>
-          <a:xfrm>
-            <a:off x="6172200" y="4572000"/>
-            <a:ext cx="5440680" cy="1280160"/>
-          </a:xfrm>
-          <a:prstGeom prst="roundRect">
-            <a:avLst>
-              <a:gd name="adj" fmla="val 8571"/>
-            </a:avLst>
-          </a:prstGeom>
-          <a:solidFill>
-            <a:schemeClr val="bg2"/>
-          </a:solidFill>
-          <a:ln w="12700">
-            <a:solidFill>
-              <a:schemeClr val="bg2"/>
-            </a:solidFill>
-            <a:prstDash val="solid"/>
-          </a:ln>
-        </p:spPr>
-        <p:txBody>
-          <a:bodyPr/>
-          <a:p/>
-        </p:txBody>
-      </p:sp>
-      <p:sp>
-        <p:nvSpPr>
-          <p:cNvPr id="25" name="Sıra"/>
-          <p:cNvSpPr/>
-          <p:nvPr/>
-        </p:nvSpPr>
-        <p:spPr>
-          <a:xfrm>
-            <a:off x="6446520" y="4818888"/>
-            <a:ext cx="786384" cy="786384"/>
-          </a:xfrm>
-          <a:prstGeom prst="ellipse">
-            <a:avLst/>
-          </a:prstGeom>
-          <a:solidFill>
-            <a:schemeClr val="accent2"/>
-          </a:solidFill>
-          <a:ln w="12700">
-            <a:solidFill>
-              <a:schemeClr val="accent2"/>
-            </a:solidFill>
-            <a:prstDash val="solid"/>
-          </a:ln>
-        </p:spPr>
-        <p:txBody>
-          <a:bodyPr/>
-          <a:p/>
-        </p:txBody>
-      </p:sp>
-      <p:sp>
-        <p:nvSpPr>
-          <p:cNvPr id="26" name="Text 15"/>
-          <p:cNvSpPr txBox="1"/>
-          <p:nvPr/>
-        </p:nvSpPr>
-        <p:spPr>
-          <a:xfrm>
-            <a:off x="6446520" y="4818888"/>
-            <a:ext cx="786384" cy="786384"/>
-          </a:xfrm>
-          <a:prstGeom prst="rect">
-            <a:avLst/>
-          </a:prstGeom>
-          <a:noFill/>
-          <a:ln/>
-        </p:spPr>
-        <p:txBody>
-          <a:bodyPr wrap="square" lIns="0" tIns="0" rIns="0" bIns="0" rtlCol="0" anchor="ctr"/>
-          <a:lstStyle/>
-          <a:p>
-            <a:pPr marL="0" indent="0" algn="ctr">
-              <a:buNone/>
-            </a:pPr>
-            <a:r>
-              <a:rPr lang="en-US" sz="2800" b="1" dirty="0">
-                <a:solidFill>
-                  <a:schemeClr val="bg1"/>
-                </a:solidFill>
-              </a:rPr>
-              <a:t>6</a:t>
-            </a:r>
-            <a:endParaRPr lang="en-US" sz="2800" dirty="0"/>
-          </a:p>
-        </p:txBody>
-      </p:sp>
-      <p:sp>
-        <p:nvSpPr>
-          <p:cNvPr id="27" name="Text 16"/>
-          <p:cNvSpPr txBox="1"/>
-          <p:nvPr/>
-        </p:nvSpPr>
-        <p:spPr>
-          <a:xfrm>
-            <a:off x="7498080" y="4572000"/>
-            <a:ext cx="3931920" cy="1280160"/>
-          </a:xfrm>
-          <a:prstGeom prst="rect">
-            <a:avLst/>
-          </a:prstGeom>
-          <a:noFill/>
-          <a:ln/>
-        </p:spPr>
-        <p:txBody>
-          <a:bodyPr wrap="square" lIns="0" tIns="0" rIns="0" bIns="0" rtlCol="0" anchor="ctr"/>
-          <a:lstStyle/>
-          <a:p>
-            <a:pPr marL="0" indent="0">
-              <a:buNone/>
-            </a:pPr>
-            <a:r>
-              <a:rPr lang="en-US" sz="2600" dirty="0">
-                <a:solidFill>
-                  <a:schemeClr val="accent1"/>
-                </a:solidFill>
-              </a:rPr>
-              <a:t>Olgu ve özet</a:t>
-            </a:r>
-            <a:endParaRPr lang="en-US" sz="2600" dirty="0"/>
           </a:p>
         </p:txBody>
       </p:sp>
@@ -10063,7 +10172,10 @@
         </p:spPr>
         <p:txBody>
           <a:bodyPr/>
-          <a:p/>
+          <a:lstStyle/>
+          <a:p>
+            <a:endParaRPr/>
+          </a:p>
         </p:txBody>
       </p:sp>
       <p:pic>
@@ -10196,7 +10308,10 @@
         </p:spPr>
         <p:txBody>
           <a:bodyPr/>
-          <a:p/>
+          <a:lstStyle/>
+          <a:p>
+            <a:endParaRPr/>
+          </a:p>
         </p:txBody>
       </p:sp>
       <p:pic>
@@ -10329,7 +10444,10 @@
         </p:spPr>
         <p:txBody>
           <a:bodyPr/>
-          <a:p/>
+          <a:lstStyle/>
+          <a:p>
+            <a:endParaRPr/>
+          </a:p>
         </p:txBody>
       </p:sp>
       <p:pic>
@@ -10462,7 +10580,10 @@
         </p:spPr>
         <p:txBody>
           <a:bodyPr/>
-          <a:p/>
+          <a:lstStyle/>
+          <a:p>
+            <a:endParaRPr/>
+          </a:p>
         </p:txBody>
       </p:sp>
       <p:pic>
@@ -10625,7 +10746,7 @@
           </a:prstGeom>
           <a:extLst>
             <a:ext uri="{C572A759-6A51-4108-AA02-DFA0A04FC94B}">
-              <ma14:wrappingTextBoxFlag xmlns:ma14="http://schemas.microsoft.com/office/mac/drawingml/2011/main" xmlns="" val="0"/>
+              <ma14:wrappingTextBoxFlag xmlns="" xmlns:ma14="http://schemas.microsoft.com/office/mac/drawingml/2011/main" val="0"/>
             </a:ext>
           </a:extLst>
         </p:spPr>
@@ -10741,7 +10862,10 @@
         </p:spPr>
         <p:txBody>
           <a:bodyPr/>
-          <a:p/>
+          <a:lstStyle/>
+          <a:p>
+            <a:endParaRPr/>
+          </a:p>
         </p:txBody>
       </p:sp>
       <p:pic>
@@ -10866,7 +10990,10 @@
         </p:spPr>
         <p:txBody>
           <a:bodyPr/>
-          <a:p/>
+          <a:lstStyle/>
+          <a:p>
+            <a:endParaRPr/>
+          </a:p>
         </p:txBody>
       </p:sp>
       <p:pic>
@@ -10999,7 +11126,10 @@
         </p:spPr>
         <p:txBody>
           <a:bodyPr/>
-          <a:p/>
+          <a:lstStyle/>
+          <a:p>
+            <a:endParaRPr/>
+          </a:p>
         </p:txBody>
       </p:sp>
       <p:pic>
@@ -11132,7 +11262,10 @@
         </p:spPr>
         <p:txBody>
           <a:bodyPr/>
-          <a:p/>
+          <a:lstStyle/>
+          <a:p>
+            <a:endParaRPr/>
+          </a:p>
         </p:txBody>
       </p:sp>
       <p:pic>
@@ -11247,7 +11380,7 @@
         </p:nvSpPr>
         <p:spPr>
           <a:xfrm>
-            <a:off x="548640" y="6382512"/>
+            <a:off x="548640" y="6394869"/>
             <a:ext cx="10424160" cy="292608"/>
           </a:xfrm>
           <a:prstGeom prst="rect">
@@ -11295,7 +11428,7 @@
           </a:prstGeom>
           <a:extLst>
             <a:ext uri="{C572A759-6A51-4108-AA02-DFA0A04FC94B}">
-              <ma14:wrappingTextBoxFlag xmlns:ma14="http://schemas.microsoft.com/office/mac/drawingml/2011/main" xmlns="" val="0"/>
+              <ma14:wrappingTextBoxFlag xmlns="" xmlns:ma14="http://schemas.microsoft.com/office/mac/drawingml/2011/main" val="0"/>
             </a:ext>
           </a:extLst>
         </p:spPr>
@@ -11799,7 +11932,7 @@
           </a:prstGeom>
           <a:extLst>
             <a:ext uri="{C572A759-6A51-4108-AA02-DFA0A04FC94B}">
-              <ma14:wrappingTextBoxFlag xmlns:ma14="http://schemas.microsoft.com/office/mac/drawingml/2011/main" xmlns="" val="0"/>
+              <ma14:wrappingTextBoxFlag xmlns="" xmlns:ma14="http://schemas.microsoft.com/office/mac/drawingml/2011/main" val="0"/>
             </a:ext>
           </a:extLst>
         </p:spPr>
@@ -12278,7 +12411,7 @@
           </a:prstGeom>
           <a:extLst>
             <a:ext uri="{C572A759-6A51-4108-AA02-DFA0A04FC94B}">
-              <ma14:wrappingTextBoxFlag xmlns:ma14="http://schemas.microsoft.com/office/mac/drawingml/2011/main" xmlns="" val="0"/>
+              <ma14:wrappingTextBoxFlag xmlns="" xmlns:ma14="http://schemas.microsoft.com/office/mac/drawingml/2011/main" val="0"/>
             </a:ext>
           </a:extLst>
         </p:spPr>
@@ -12312,510 +12445,6 @@
 </file>
 
 <file path=ppt/slides/slide24.xml><?xml version="1.0" encoding="utf-8"?>
-<p:sld xmlns:a="http://schemas.openxmlformats.org/drawingml/2006/main" xmlns:r="http://schemas.openxmlformats.org/officeDocument/2006/relationships" xmlns:p="http://schemas.openxmlformats.org/presentationml/2006/main">
-  <p:cSld name="Slide 25">
-    <p:spTree>
-      <p:nvGrpSpPr>
-        <p:cNvPr id="1" name=""/>
-        <p:cNvGrpSpPr/>
-        <p:nvPr/>
-      </p:nvGrpSpPr>
-      <p:grpSpPr>
-        <a:xfrm>
-          <a:off x="0" y="0"/>
-          <a:ext cx="0" cy="0"/>
-          <a:chOff x="0" y="0"/>
-          <a:chExt cx="0" cy="0"/>
-        </a:xfrm>
-      </p:grpSpPr>
-      <p:sp>
-        <p:nvSpPr>
-          <p:cNvPr id="3" name="Text 0"/>
-          <p:cNvSpPr>
-            <a:spLocks noGrp="1"/>
-          </p:cNvSpPr>
-          <p:nvPr>
-            <p:ph type="title" idx="100" hasCustomPrompt="1"/>
-          </p:nvPr>
-        </p:nvSpPr>
-        <p:spPr>
-          <a:xfrm>
-            <a:off x="548640" y="320040"/>
-            <a:ext cx="10607040" cy="868680"/>
-          </a:xfrm>
-          <a:prstGeom prst="rect">
-            <a:avLst/>
-          </a:prstGeom>
-          <a:noFill/>
-          <a:ln/>
-        </p:spPr>
-        <p:txBody>
-          <a:bodyPr wrap="square" lIns="0" tIns="0" rIns="0" bIns="0" rtlCol="0" anchor="ctr"/>
-          <a:lstStyle/>
-          <a:p>
-            <a:pPr marL="0" indent="0" algn="l">
-              <a:buNone/>
-            </a:pPr>
-            <a:r>
-              <a:rPr lang="en-US" sz="3600" b="1" dirty="0">
-                <a:solidFill>
-                  <a:schemeClr val="accent1"/>
-                </a:solidFill>
-              </a:rPr>
-              <a:t>Olgu: Siz ne yapardınız?</a:t>
-            </a:r>
-            <a:endParaRPr lang="en-US" sz="3600" dirty="0"/>
-          </a:p>
-        </p:txBody>
-      </p:sp>
-      <p:sp>
-        <p:nvSpPr>
-          <p:cNvPr id="4" name="Kart"/>
-          <p:cNvSpPr/>
-          <p:nvPr/>
-        </p:nvSpPr>
-        <p:spPr>
-          <a:xfrm>
-            <a:off x="548640" y="1371600"/>
-            <a:ext cx="5760720" cy="4572000"/>
-          </a:xfrm>
-          <a:prstGeom prst="roundRect">
-            <a:avLst>
-              <a:gd name="adj" fmla="val 2400"/>
-            </a:avLst>
-          </a:prstGeom>
-          <a:solidFill>
-            <a:schemeClr val="bg2"/>
-          </a:solidFill>
-          <a:ln w="12700">
-            <a:solidFill>
-              <a:schemeClr val="bg2"/>
-            </a:solidFill>
-            <a:prstDash val="solid"/>
-          </a:ln>
-        </p:spPr>
-      </p:sp>
-      <p:sp>
-        <p:nvSpPr>
-          <p:cNvPr id="5" name="Ikon zemini"/>
-          <p:cNvSpPr/>
-          <p:nvPr/>
-        </p:nvSpPr>
-        <p:spPr>
-          <a:xfrm>
-            <a:off x="822960" y="1600200"/>
-            <a:ext cx="822960" cy="822960"/>
-          </a:xfrm>
-          <a:prstGeom prst="ellipse">
-            <a:avLst/>
-          </a:prstGeom>
-          <a:solidFill>
-            <a:schemeClr val="accent2"/>
-          </a:solidFill>
-          <a:ln w="12700">
-            <a:solidFill>
-              <a:schemeClr val="accent2"/>
-            </a:solidFill>
-            <a:prstDash val="solid"/>
-          </a:ln>
-        </p:spPr>
-      </p:sp>
-      <p:pic>
-        <p:nvPicPr>
-          <p:cNvPr id="6" name="Ikon" descr="FaUserMd"/>
-          <p:cNvPicPr>
-            <a:picLocks noChangeAspect="1"/>
-          </p:cNvPicPr>
-          <p:nvPr/>
-        </p:nvPicPr>
-        <p:blipFill>
-          <a:blip r:embed="rId3"/>
-          <a:stretch>
-            <a:fillRect/>
-          </a:stretch>
-        </p:blipFill>
-        <p:spPr>
-          <a:xfrm>
-            <a:off x="1036930" y="1814170"/>
-            <a:ext cx="395021" cy="395021"/>
-          </a:xfrm>
-          <a:prstGeom prst="rect">
-            <a:avLst/>
-          </a:prstGeom>
-        </p:spPr>
-      </p:pic>
-      <p:sp>
-        <p:nvSpPr>
-          <p:cNvPr id="7" name="Text 3"/>
-          <p:cNvSpPr txBox="1"/>
-          <p:nvPr/>
-        </p:nvSpPr>
-        <p:spPr>
-          <a:xfrm>
-            <a:off x="1828800" y="1600200"/>
-            <a:ext cx="4297680" cy="822960"/>
-          </a:xfrm>
-          <a:prstGeom prst="rect">
-            <a:avLst/>
-          </a:prstGeom>
-          <a:noFill/>
-          <a:ln/>
-        </p:spPr>
-        <p:txBody>
-          <a:bodyPr wrap="square" lIns="0" tIns="0" rIns="0" bIns="0" rtlCol="0" anchor="ctr"/>
-          <a:lstStyle/>
-          <a:p>
-            <a:pPr marL="0" indent="0">
-              <a:buNone/>
-            </a:pPr>
-            <a:r>
-              <a:rPr lang="en-US" sz="2600" b="1" dirty="0">
-                <a:solidFill>
-                  <a:schemeClr val="accent1"/>
-                </a:solidFill>
-              </a:rPr>
-              <a:t>52 yaşında erkek hasta</a:t>
-            </a:r>
-            <a:endParaRPr lang="en-US" sz="2600" dirty="0"/>
-          </a:p>
-        </p:txBody>
-      </p:sp>
-      <p:sp>
-        <p:nvSpPr>
-          <p:cNvPr id="8" name="Text 4"/>
-          <p:cNvSpPr txBox="1"/>
-          <p:nvPr/>
-        </p:nvSpPr>
-        <p:spPr>
-          <a:xfrm>
-            <a:off x="914400" y="2697480"/>
-            <a:ext cx="5120640" cy="3017520"/>
-          </a:xfrm>
-          <a:prstGeom prst="rect">
-            <a:avLst/>
-          </a:prstGeom>
-          <a:noFill/>
-          <a:ln/>
-        </p:spPr>
-        <p:txBody>
-          <a:bodyPr wrap="square" lIns="0" tIns="0" rIns="0" bIns="0" rtlCol="0" anchor="t"/>
-          <a:lstStyle/>
-          <a:p>
-            <a:pPr marL="279400" indent="-279400" algn="just">
-              <a:spcAft>
-                <a:spcPts val="1400"/>
-              </a:spcAft>
-              <a:buSzPct val="100000"/>
-              <a:buChar char="•"/>
-            </a:pPr>
-            <a:r>
-              <a:rPr lang="en-US" sz="2200" dirty="0">
-                <a:solidFill>
-                  <a:schemeClr val="accent1"/>
-                </a:solidFill>
-              </a:rPr>
-              <a:t>Günde 25 sigara, 30 paket-yıl</a:t>
-            </a:r>
-            <a:endParaRPr lang="en-US" sz="2200" dirty="0"/>
-          </a:p>
-          <a:p>
-            <a:pPr marL="279400" indent="-279400" algn="just">
-              <a:spcAft>
-                <a:spcPts val="1400"/>
-              </a:spcAft>
-              <a:buSzPct val="100000"/>
-              <a:buChar char="•"/>
-            </a:pPr>
-            <a:r>
-              <a:rPr lang="en-US" sz="2200" dirty="0">
-                <a:solidFill>
-                  <a:schemeClr val="accent1"/>
-                </a:solidFill>
-              </a:rPr>
-              <a:t>FNBT: 8 (yüksek bağımlılık)</a:t>
-            </a:r>
-            <a:endParaRPr lang="en-US" sz="2200" dirty="0"/>
-          </a:p>
-          <a:p>
-            <a:pPr marL="279400" indent="-279400" algn="just">
-              <a:spcAft>
-                <a:spcPts val="1400"/>
-              </a:spcAft>
-              <a:buSzPct val="100000"/>
-              <a:buChar char="•"/>
-            </a:pPr>
-            <a:r>
-              <a:rPr lang="en-US" sz="2200" dirty="0">
-                <a:solidFill>
-                  <a:schemeClr val="accent1"/>
-                </a:solidFill>
-              </a:rPr>
-              <a:t>Bupropion ile başarısız deneme</a:t>
-            </a:r>
-            <a:endParaRPr lang="en-US" sz="2200" dirty="0"/>
-          </a:p>
-          <a:p>
-            <a:pPr marL="279400" indent="-279400" algn="just">
-              <a:spcAft>
-                <a:spcPts val="1400"/>
-              </a:spcAft>
-              <a:buSzPct val="100000"/>
-              <a:buChar char="•"/>
-            </a:pPr>
-            <a:r>
-              <a:rPr lang="en-US" sz="2200" dirty="0">
-                <a:solidFill>
-                  <a:schemeClr val="accent1"/>
-                </a:solidFill>
-              </a:rPr>
-              <a:t>Eşi de sigara içiyor</a:t>
-            </a:r>
-            <a:endParaRPr lang="en-US" sz="2200" dirty="0"/>
-          </a:p>
-        </p:txBody>
-      </p:sp>
-      <p:sp>
-        <p:nvSpPr>
-          <p:cNvPr id="9" name="Kart"/>
-          <p:cNvSpPr/>
-          <p:nvPr/>
-        </p:nvSpPr>
-        <p:spPr>
-          <a:xfrm>
-            <a:off x="6583680" y="1371600"/>
-            <a:ext cx="5029200" cy="4572000"/>
-          </a:xfrm>
-          <a:prstGeom prst="roundRect">
-            <a:avLst>
-              <a:gd name="adj" fmla="val 2400"/>
-            </a:avLst>
-          </a:prstGeom>
-          <a:solidFill>
-            <a:schemeClr val="accent1"/>
-          </a:solidFill>
-          <a:ln w="12700">
-            <a:solidFill>
-              <a:schemeClr val="accent1"/>
-            </a:solidFill>
-            <a:prstDash val="solid"/>
-          </a:ln>
-        </p:spPr>
-      </p:sp>
-      <p:sp>
-        <p:nvSpPr>
-          <p:cNvPr id="10" name="Ikon zemini"/>
-          <p:cNvSpPr/>
-          <p:nvPr/>
-        </p:nvSpPr>
-        <p:spPr>
-          <a:xfrm>
-            <a:off x="6858000" y="1600200"/>
-            <a:ext cx="822960" cy="822960"/>
-          </a:xfrm>
-          <a:prstGeom prst="ellipse">
-            <a:avLst/>
-          </a:prstGeom>
-          <a:solidFill>
-            <a:schemeClr val="accent2"/>
-          </a:solidFill>
-          <a:ln w="12700">
-            <a:solidFill>
-              <a:schemeClr val="accent2"/>
-            </a:solidFill>
-            <a:prstDash val="solid"/>
-          </a:ln>
-        </p:spPr>
-      </p:sp>
-      <p:pic>
-        <p:nvPicPr>
-          <p:cNvPr id="11" name="Ikon" descr="FaQuestion"/>
-          <p:cNvPicPr>
-            <a:picLocks noChangeAspect="1"/>
-          </p:cNvPicPr>
-          <p:nvPr/>
-        </p:nvPicPr>
-        <p:blipFill>
-          <a:blip r:embed="rId4"/>
-          <a:stretch>
-            <a:fillRect/>
-          </a:stretch>
-        </p:blipFill>
-        <p:spPr>
-          <a:xfrm>
-            <a:off x="7071970" y="1814170"/>
-            <a:ext cx="395021" cy="395021"/>
-          </a:xfrm>
-          <a:prstGeom prst="rect">
-            <a:avLst/>
-          </a:prstGeom>
-        </p:spPr>
-      </p:pic>
-      <p:sp>
-        <p:nvSpPr>
-          <p:cNvPr id="12" name="Text 7"/>
-          <p:cNvSpPr txBox="1"/>
-          <p:nvPr/>
-        </p:nvSpPr>
-        <p:spPr>
-          <a:xfrm>
-            <a:off x="7863840" y="1600200"/>
-            <a:ext cx="3566160" cy="822960"/>
-          </a:xfrm>
-          <a:prstGeom prst="rect">
-            <a:avLst/>
-          </a:prstGeom>
-          <a:noFill/>
-          <a:ln/>
-        </p:spPr>
-        <p:txBody>
-          <a:bodyPr wrap="square" lIns="0" tIns="0" rIns="0" bIns="0" rtlCol="0" anchor="ctr"/>
-          <a:lstStyle/>
-          <a:p>
-            <a:pPr marL="0" indent="0">
-              <a:buNone/>
-            </a:pPr>
-            <a:r>
-              <a:rPr lang="en-US" sz="2600" b="1" dirty="0">
-                <a:solidFill>
-                  <a:schemeClr val="bg1"/>
-                </a:solidFill>
-              </a:rPr>
-              <a:t>Tartışalım</a:t>
-            </a:r>
-            <a:endParaRPr lang="en-US" sz="2600" dirty="0"/>
-          </a:p>
-        </p:txBody>
-      </p:sp>
-      <p:sp>
-        <p:nvSpPr>
-          <p:cNvPr id="13" name="Text 8"/>
-          <p:cNvSpPr txBox="1"/>
-          <p:nvPr/>
-        </p:nvSpPr>
-        <p:spPr>
-          <a:xfrm>
-            <a:off x="6949440" y="2697480"/>
-            <a:ext cx="4389120" cy="3017520"/>
-          </a:xfrm>
-          <a:prstGeom prst="rect">
-            <a:avLst/>
-          </a:prstGeom>
-          <a:noFill/>
-          <a:ln/>
-        </p:spPr>
-        <p:txBody>
-          <a:bodyPr wrap="square" lIns="0" tIns="0" rIns="0" bIns="0" rtlCol="0" anchor="t"/>
-          <a:lstStyle/>
-          <a:p>
-            <a:pPr marL="279400" indent="-279400" algn="just">
-              <a:spcAft>
-                <a:spcPts val="1800"/>
-              </a:spcAft>
-              <a:buSzPct val="100000"/>
-              <a:buChar char="•"/>
-            </a:pPr>
-            <a:r>
-              <a:rPr lang="en-US" sz="2200" dirty="0">
-                <a:solidFill>
-                  <a:schemeClr val="bg1"/>
-                </a:solidFill>
-              </a:rPr>
-              <a:t>Hangi tedaviyi seçerdiniz?</a:t>
-            </a:r>
-            <a:endParaRPr lang="en-US" sz="2200" dirty="0"/>
-          </a:p>
-          <a:p>
-            <a:pPr marL="279400" indent="-279400" algn="just">
-              <a:spcAft>
-                <a:spcPts val="1800"/>
-              </a:spcAft>
-              <a:buSzPct val="100000"/>
-              <a:buChar char="•"/>
-            </a:pPr>
-            <a:r>
-              <a:rPr lang="en-US" sz="2200" dirty="0">
-                <a:solidFill>
-                  <a:schemeClr val="bg1"/>
-                </a:solidFill>
-              </a:rPr>
-              <a:t>Takibi nasıl planlardınız?</a:t>
-            </a:r>
-            <a:endParaRPr lang="en-US" sz="2200" dirty="0"/>
-          </a:p>
-          <a:p>
-            <a:pPr marL="279400" indent="-279400" algn="just">
-              <a:spcAft>
-                <a:spcPts val="1800"/>
-              </a:spcAft>
-              <a:buSzPct val="100000"/>
-              <a:buChar char="•"/>
-            </a:pPr>
-            <a:r>
-              <a:rPr lang="en-US" sz="2200" dirty="0">
-                <a:solidFill>
-                  <a:schemeClr val="bg1"/>
-                </a:solidFill>
-              </a:rPr>
-              <a:t>Eşi sürece nasıl katılmalı?</a:t>
-            </a:r>
-            <a:endParaRPr lang="en-US" sz="2200" dirty="0"/>
-          </a:p>
-        </p:txBody>
-      </p:sp>
-      <p:sp>
-        <p:nvSpPr>
-          <p:cNvPr id="25" name="Slide Number Placeholder 0"/>
-          <p:cNvSpPr>
-            <a:spLocks noGrp="1"/>
-          </p:cNvSpPr>
-          <p:nvPr>
-            <p:ph type="sldNum" sz="quarter" idx="4294967295"/>
-          </p:nvPr>
-        </p:nvSpPr>
-        <p:spPr>
-          <a:xfrm>
-            <a:off x="11201400" y="6382512"/>
-            <a:ext cx="548640" cy="292608"/>
-          </a:xfrm>
-          <a:prstGeom prst="rect">
-            <a:avLst/>
-          </a:prstGeom>
-          <a:extLst>
-            <a:ext uri="{C572A759-6A51-4108-AA02-DFA0A04FC94B}">
-              <ma14:wrappingTextBoxFlag xmlns:ma14="http://schemas.microsoft.com/office/mac/drawingml/2011/main" xmlns="" val="0"/>
-            </a:ext>
-          </a:extLst>
-        </p:spPr>
-        <p:txBody>
-          <a:bodyPr/>
-          <a:lstStyle>
-            <a:lvl1pPr>
-              <a:defRPr sz="1400">
-                <a:solidFill>
-                  <a:srgbClr val="7A8C94"/>
-                </a:solidFill>
-              </a:defRPr>
-            </a:lvl1pPr>
-          </a:lstStyle>
-          <a:p>
-            <a:pPr algn="r"/>
-            <a:fld id="{F7021451-1387-4CA6-816F-3879F97B5CBC}" type="slidenum">
-              <a:rPr lang="en-US" b="0"/>
-              <a:t>24</a:t>
-            </a:fld>
-            <a:endParaRPr lang="en-US"/>
-          </a:p>
-        </p:txBody>
-      </p:sp>
-    </p:spTree>
-  </p:cSld>
-  <p:clrMapOvr>
-    <a:masterClrMapping/>
-  </p:clrMapOvr>
-</p:sld>
-</file>
-
-<file path=ppt/slides/slide25.xml><?xml version="1.0" encoding="utf-8"?>
 <p:sld xmlns:a="http://schemas.openxmlformats.org/drawingml/2006/main" xmlns:r="http://schemas.openxmlformats.org/officeDocument/2006/relationships" xmlns:p="http://schemas.openxmlformats.org/presentationml/2006/main">
   <p:cSld name="Slide 26">
     <p:spTree>
@@ -12898,7 +12527,10 @@
         </p:spPr>
         <p:txBody>
           <a:bodyPr/>
-          <a:p/>
+          <a:lstStyle/>
+          <a:p>
+            <a:endParaRPr/>
+          </a:p>
         </p:txBody>
       </p:sp>
       <p:pic>
@@ -12987,7 +12619,10 @@
         </p:spPr>
         <p:txBody>
           <a:bodyPr/>
-          <a:p/>
+          <a:lstStyle/>
+          <a:p>
+            <a:endParaRPr/>
+          </a:p>
         </p:txBody>
       </p:sp>
       <p:pic>
@@ -13076,7 +12711,10 @@
         </p:spPr>
         <p:txBody>
           <a:bodyPr/>
-          <a:p/>
+          <a:lstStyle/>
+          <a:p>
+            <a:endParaRPr/>
+          </a:p>
         </p:txBody>
       </p:sp>
       <p:pic>
@@ -13165,7 +12803,10 @@
         </p:spPr>
         <p:txBody>
           <a:bodyPr/>
-          <a:p/>
+          <a:lstStyle/>
+          <a:p>
+            <a:endParaRPr/>
+          </a:p>
         </p:txBody>
       </p:sp>
       <p:pic>
@@ -13254,7 +12895,10 @@
         </p:spPr>
         <p:txBody>
           <a:bodyPr/>
-          <a:p/>
+          <a:lstStyle/>
+          <a:p>
+            <a:endParaRPr/>
+          </a:p>
         </p:txBody>
       </p:sp>
       <p:pic>
@@ -13373,7 +13017,7 @@
           </a:prstGeom>
           <a:extLst>
             <a:ext uri="{C572A759-6A51-4108-AA02-DFA0A04FC94B}">
-              <ma14:wrappingTextBoxFlag xmlns:ma14="http://schemas.microsoft.com/office/mac/drawingml/2011/main" xmlns="" val="0"/>
+              <ma14:wrappingTextBoxFlag xmlns="" xmlns:ma14="http://schemas.microsoft.com/office/mac/drawingml/2011/main" val="0"/>
             </a:ext>
           </a:extLst>
         </p:spPr>
@@ -13392,7 +13036,7 @@
             <a:pPr algn="r"/>
             <a:fld id="{F7021451-1387-4CA6-816F-3879F97B5CBC}" type="slidenum">
               <a:rPr lang="en-US" b="0"/>
-              <a:t>25</a:t>
+              <a:t>24</a:t>
             </a:fld>
             <a:endParaRPr lang="en-US"/>
           </a:p>
@@ -13406,7 +13050,7 @@
 </p:sld>
 </file>
 
-<file path=ppt/slides/slide26.xml><?xml version="1.0" encoding="utf-8"?>
+<file path=ppt/slides/slide25.xml><?xml version="1.0" encoding="utf-8"?>
 <p:sld xmlns:a="http://schemas.openxmlformats.org/drawingml/2006/main" xmlns:r="http://schemas.openxmlformats.org/officeDocument/2006/relationships" xmlns:p="http://schemas.openxmlformats.org/presentationml/2006/main">
   <p:cSld name="Slide 27">
     <p:spTree>
@@ -13831,7 +13475,7 @@
           </a:prstGeom>
           <a:extLst>
             <a:ext uri="{C572A759-6A51-4108-AA02-DFA0A04FC94B}">
-              <ma14:wrappingTextBoxFlag xmlns:ma14="http://schemas.microsoft.com/office/mac/drawingml/2011/main" xmlns="" val="0"/>
+              <ma14:wrappingTextBoxFlag xmlns="" xmlns:ma14="http://schemas.microsoft.com/office/mac/drawingml/2011/main" val="0"/>
             </a:ext>
           </a:extLst>
         </p:spPr>
@@ -13850,7 +13494,7 @@
             <a:pPr algn="r"/>
             <a:fld id="{F7021451-1387-4CA6-816F-3879F97B5CBC}" type="slidenum">
               <a:rPr lang="en-US" b="0"/>
-              <a:t>26</a:t>
+              <a:t>25</a:t>
             </a:fld>
             <a:endParaRPr lang="en-US"/>
           </a:p>
@@ -13864,7 +13508,7 @@
 </p:sld>
 </file>
 
-<file path=ppt/slides/slide27.xml><?xml version="1.0" encoding="utf-8"?>
+<file path=ppt/slides/slide26.xml><?xml version="1.0" encoding="utf-8"?>
 <p:sld xmlns:a="http://schemas.openxmlformats.org/drawingml/2006/main" xmlns:r="http://schemas.openxmlformats.org/officeDocument/2006/relationships" xmlns:p="http://schemas.openxmlformats.org/presentationml/2006/main">
   <p:cSld name="Slide 28">
     <p:spTree>
@@ -13946,20 +13590,6 @@
               <a:buNone/>
             </a:pPr>
             <a:r>
-              <a:rPr lang="en-US" sz="2600" b="1" dirty="0">
-                <a:solidFill>
-                  <a:schemeClr val="bg2"/>
-                </a:solidFill>
-              </a:rPr>
-              <a:t>Sorular ve tartışma</a:t>
-            </a:r>
-            <a:endParaRPr lang="en-US" sz="2600" dirty="0"/>
-          </a:p>
-          <a:p>
-            <a:pPr marL="0" indent="0">
-              <a:buNone/>
-            </a:pPr>
-            <a:r>
               <a:rPr lang="en-US" sz="1200" dirty="0">
                 <a:solidFill>
                   <a:schemeClr val="bg2"/>
@@ -14011,7 +13641,10 @@
         </p:spPr>
         <p:txBody>
           <a:bodyPr/>
-          <a:p/>
+          <a:lstStyle/>
+          <a:p>
+            <a:endParaRPr/>
+          </a:p>
         </p:txBody>
       </p:sp>
       <p:pic>
@@ -14094,7 +13727,7 @@
           </a:prstGeom>
           <a:extLst>
             <a:ext uri="{C572A759-6A51-4108-AA02-DFA0A04FC94B}">
-              <ma14:wrappingTextBoxFlag xmlns:ma14="http://schemas.microsoft.com/office/mac/drawingml/2011/main" xmlns="" val="0"/>
+              <ma14:wrappingTextBoxFlag xmlns="" xmlns:ma14="http://schemas.microsoft.com/office/mac/drawingml/2011/main" val="0"/>
             </a:ext>
           </a:extLst>
         </p:spPr>
@@ -14113,7 +13746,7 @@
             <a:pPr algn="r"/>
             <a:fld id="{F7021451-1387-4CA6-816F-3879F97B5CBC}" type="slidenum">
               <a:rPr lang="en-US" b="0"/>
-              <a:t>27</a:t>
+              <a:t>26</a:t>
             </a:fld>
             <a:endParaRPr lang="en-US"/>
           </a:p>
@@ -14404,7 +14037,7 @@
         </p:nvSpPr>
         <p:spPr>
           <a:xfrm>
-            <a:off x="5259012" y="3776472"/>
+            <a:off x="5259012" y="2962656"/>
             <a:ext cx="1508760" cy="640080"/>
           </a:xfrm>
           <a:prstGeom prst="rect">
@@ -14440,7 +14073,7 @@
         </p:nvSpPr>
         <p:spPr>
           <a:xfrm>
-            <a:off x="6813492" y="3776472"/>
+            <a:off x="6813492" y="2962656"/>
             <a:ext cx="4826820" cy="640080"/>
           </a:xfrm>
           <a:prstGeom prst="rect">
@@ -14478,7 +14111,7 @@
         </p:nvSpPr>
         <p:spPr>
           <a:xfrm>
-            <a:off x="5259012" y="4562856"/>
+            <a:off x="5259012" y="3749040"/>
             <a:ext cx="1508760" cy="640080"/>
           </a:xfrm>
           <a:prstGeom prst="rect">
@@ -14514,7 +14147,7 @@
         </p:nvSpPr>
         <p:spPr>
           <a:xfrm>
-            <a:off x="6813492" y="4562856"/>
+            <a:off x="6813492" y="3749040"/>
             <a:ext cx="4826820" cy="640080"/>
           </a:xfrm>
           <a:prstGeom prst="rect">
@@ -14552,7 +14185,7 @@
         </p:nvSpPr>
         <p:spPr>
           <a:xfrm>
-            <a:off x="5259012" y="5349240"/>
+            <a:off x="5259012" y="4535424"/>
             <a:ext cx="1508760" cy="640080"/>
           </a:xfrm>
           <a:prstGeom prst="rect">
@@ -14588,7 +14221,7 @@
         </p:nvSpPr>
         <p:spPr>
           <a:xfrm>
-            <a:off x="6813492" y="5349240"/>
+            <a:off x="6813492" y="4535424"/>
             <a:ext cx="4826820" cy="640080"/>
           </a:xfrm>
           <a:prstGeom prst="rect">
@@ -14674,7 +14307,7 @@
           </a:prstGeom>
           <a:extLst>
             <a:ext uri="{C572A759-6A51-4108-AA02-DFA0A04FC94B}">
-              <ma14:wrappingTextBoxFlag xmlns:ma14="http://schemas.microsoft.com/office/mac/drawingml/2011/main" xmlns="" val="0"/>
+              <ma14:wrappingTextBoxFlag xmlns="" xmlns:ma14="http://schemas.microsoft.com/office/mac/drawingml/2011/main" val="0"/>
             </a:ext>
           </a:extLst>
         </p:spPr>
@@ -15412,7 +15045,7 @@
           </a:prstGeom>
           <a:extLst>
             <a:ext uri="{C572A759-6A51-4108-AA02-DFA0A04FC94B}">
-              <ma14:wrappingTextBoxFlag xmlns:ma14="http://schemas.microsoft.com/office/mac/drawingml/2011/main" xmlns="" val="0"/>
+              <ma14:wrappingTextBoxFlag xmlns="" xmlns:ma14="http://schemas.microsoft.com/office/mac/drawingml/2011/main" val="0"/>
             </a:ext>
           </a:extLst>
         </p:spPr>
@@ -15530,7 +15163,10 @@
         </p:spPr>
         <p:txBody>
           <a:bodyPr/>
-          <a:p/>
+          <a:lstStyle/>
+          <a:p>
+            <a:endParaRPr/>
+          </a:p>
         </p:txBody>
       </p:sp>
       <p:sp>
@@ -15559,7 +15195,10 @@
         </p:spPr>
         <p:txBody>
           <a:bodyPr/>
-          <a:p/>
+          <a:lstStyle/>
+          <a:p>
+            <a:endParaRPr/>
+          </a:p>
         </p:txBody>
       </p:sp>
       <p:pic>
@@ -15762,7 +15401,10 @@
         </p:spPr>
         <p:txBody>
           <a:bodyPr/>
-          <a:p/>
+          <a:lstStyle/>
+          <a:p>
+            <a:endParaRPr/>
+          </a:p>
         </p:txBody>
       </p:sp>
       <p:sp>
@@ -15791,7 +15433,10 @@
         </p:spPr>
         <p:txBody>
           <a:bodyPr/>
-          <a:p/>
+          <a:lstStyle/>
+          <a:p>
+            <a:endParaRPr/>
+          </a:p>
         </p:txBody>
       </p:sp>
       <p:pic>
@@ -16040,7 +15685,7 @@
           </a:prstGeom>
           <a:extLst>
             <a:ext uri="{C572A759-6A51-4108-AA02-DFA0A04FC94B}">
-              <ma14:wrappingTextBoxFlag xmlns:ma14="http://schemas.microsoft.com/office/mac/drawingml/2011/main" xmlns="" val="0"/>
+              <ma14:wrappingTextBoxFlag xmlns="" xmlns:ma14="http://schemas.microsoft.com/office/mac/drawingml/2011/main" val="0"/>
             </a:ext>
           </a:extLst>
         </p:spPr>
@@ -16320,7 +15965,7 @@
           </a:prstGeom>
           <a:extLst>
             <a:ext uri="{C572A759-6A51-4108-AA02-DFA0A04FC94B}">
-              <ma14:wrappingTextBoxFlag xmlns:ma14="http://schemas.microsoft.com/office/mac/drawingml/2011/main" xmlns="" val="0"/>
+              <ma14:wrappingTextBoxFlag xmlns="" xmlns:ma14="http://schemas.microsoft.com/office/mac/drawingml/2011/main" val="0"/>
             </a:ext>
           </a:extLst>
         </p:spPr>
@@ -17020,7 +16665,7 @@
           </a:prstGeom>
           <a:extLst>
             <a:ext uri="{C572A759-6A51-4108-AA02-DFA0A04FC94B}">
-              <ma14:wrappingTextBoxFlag xmlns:ma14="http://schemas.microsoft.com/office/mac/drawingml/2011/main" xmlns="" val="0"/>
+              <ma14:wrappingTextBoxFlag xmlns="" xmlns:ma14="http://schemas.microsoft.com/office/mac/drawingml/2011/main" val="0"/>
             </a:ext>
           </a:extLst>
         </p:spPr>
@@ -17877,7 +17522,7 @@
           </a:prstGeom>
           <a:extLst>
             <a:ext uri="{C572A759-6A51-4108-AA02-DFA0A04FC94B}">
-              <ma14:wrappingTextBoxFlag xmlns:ma14="http://schemas.microsoft.com/office/mac/drawingml/2011/main" xmlns="" val="0"/>
+              <ma14:wrappingTextBoxFlag xmlns="" xmlns:ma14="http://schemas.microsoft.com/office/mac/drawingml/2011/main" val="0"/>
             </a:ext>
           </a:extLst>
         </p:spPr>
@@ -18525,7 +18170,7 @@
           </a:prstGeom>
           <a:extLst>
             <a:ext uri="{C572A759-6A51-4108-AA02-DFA0A04FC94B}">
-              <ma14:wrappingTextBoxFlag xmlns:ma14="http://schemas.microsoft.com/office/mac/drawingml/2011/main" xmlns="" val="0"/>
+              <ma14:wrappingTextBoxFlag xmlns="" xmlns:ma14="http://schemas.microsoft.com/office/mac/drawingml/2011/main" val="0"/>
             </a:ext>
           </a:extLst>
         </p:spPr>

</xml_diff>

<commit_message>
Konuşma notlarını sunumun Son2 sürümüne göre güncelle
Co-Authored-By: Claude Opus 5.5 <noreply@anthropic.com>
Claude-Session: https://claude.ai/code/session_013LLNDYinKcb3EYpgyk92AX
</commit_message>
<xml_diff>
--- a/Sunumlar/Makale_Sunumu_Sigara_Birakma.pptx
+++ b/Sunumlar/Makale_Sunumu_Sigara_Birakma.pptx
@@ -373,8 +373,8 @@
               <a:t>, </a:t>
             </a:r>
             <a:r>
-              <a:rPr dirty="0" err="1"/>
-              <a:t>değerli</a:t>
+              <a:rPr lang="tr-TR" dirty="0"/>
+              <a:t>asistan</a:t>
             </a:r>
             <a:r>
               <a:rPr dirty="0"/>
@@ -722,17 +722,292 @@
           <a:lstStyle/>
           <a:p>
             <a:r>
-              <a:t>Analizler SPSS 25 ile yapılmıştır. Normallik histogram ve Kolmogorov–Smirnov testiyle değerlendirilmiştir.</a:t>
-            </a:r>
-          </a:p>
-          <a:p>
-            <a:r>
-              <a:t>Kategorik değişkenler ki-kare testiyle, iki grup karşılaştırmaları Mann–Whitney U, ikiden fazla grup karşılaştırmaları Kruskal–Wallis testiyle yapılmıştır. Post-hoc karşılaştırmalarda Duncan testi kullanılmıştır.</a:t>
-            </a:r>
-          </a:p>
-          <a:p>
-            <a:r>
-              <a:t>Tedavi yöntemlerinin bırakma üzerindeki etkisi ikili lojistik regresyonla değerlendirilmiş ve Bonferroni düzeltmesi uygulanmıştır.</a:t>
+              <a:rPr lang="tr-TR" dirty="0"/>
+              <a:t>Bu slaytı geçelim. </a:t>
+            </a:r>
+            <a:r>
+              <a:rPr dirty="0" err="1"/>
+              <a:t>Analizler</a:t>
+            </a:r>
+            <a:r>
+              <a:rPr dirty="0"/>
+              <a:t> SPSS 25 </a:t>
+            </a:r>
+            <a:r>
+              <a:rPr dirty="0" err="1"/>
+              <a:t>ile</a:t>
+            </a:r>
+            <a:r>
+              <a:rPr dirty="0"/>
+              <a:t> </a:t>
+            </a:r>
+            <a:r>
+              <a:rPr dirty="0" err="1"/>
+              <a:t>yapılmıştır</a:t>
+            </a:r>
+            <a:r>
+              <a:rPr dirty="0"/>
+              <a:t>. </a:t>
+            </a:r>
+            <a:r>
+              <a:rPr dirty="0" err="1"/>
+              <a:t>Normallik</a:t>
+            </a:r>
+            <a:r>
+              <a:rPr dirty="0"/>
+              <a:t> histogram </a:t>
+            </a:r>
+            <a:r>
+              <a:rPr dirty="0" err="1"/>
+              <a:t>ve</a:t>
+            </a:r>
+            <a:r>
+              <a:rPr dirty="0"/>
+              <a:t> Kolmogorov–Smirnov </a:t>
+            </a:r>
+            <a:r>
+              <a:rPr dirty="0" err="1"/>
+              <a:t>testiyle</a:t>
+            </a:r>
+            <a:r>
+              <a:rPr dirty="0"/>
+              <a:t> </a:t>
+            </a:r>
+            <a:r>
+              <a:rPr dirty="0" err="1"/>
+              <a:t>değerlendirilmiştir</a:t>
+            </a:r>
+            <a:r>
+              <a:rPr dirty="0"/>
+              <a:t>.</a:t>
+            </a:r>
+          </a:p>
+          <a:p>
+            <a:r>
+              <a:rPr dirty="0" err="1"/>
+              <a:t>Kategorik</a:t>
+            </a:r>
+            <a:r>
+              <a:rPr dirty="0"/>
+              <a:t> </a:t>
+            </a:r>
+            <a:r>
+              <a:rPr dirty="0" err="1"/>
+              <a:t>değişkenler</a:t>
+            </a:r>
+            <a:r>
+              <a:rPr dirty="0"/>
+              <a:t> ki-</a:t>
+            </a:r>
+            <a:r>
+              <a:rPr dirty="0" err="1"/>
+              <a:t>kare</a:t>
+            </a:r>
+            <a:r>
+              <a:rPr dirty="0"/>
+              <a:t> </a:t>
+            </a:r>
+            <a:r>
+              <a:rPr dirty="0" err="1"/>
+              <a:t>testiyle</a:t>
+            </a:r>
+            <a:r>
+              <a:rPr dirty="0"/>
+              <a:t>, </a:t>
+            </a:r>
+            <a:r>
+              <a:rPr dirty="0" err="1"/>
+              <a:t>iki</a:t>
+            </a:r>
+            <a:r>
+              <a:rPr dirty="0"/>
+              <a:t> </a:t>
+            </a:r>
+            <a:r>
+              <a:rPr dirty="0" err="1"/>
+              <a:t>grup</a:t>
+            </a:r>
+            <a:r>
+              <a:rPr dirty="0"/>
+              <a:t> </a:t>
+            </a:r>
+            <a:r>
+              <a:rPr dirty="0" err="1"/>
+              <a:t>karşılaştırmaları</a:t>
+            </a:r>
+            <a:r>
+              <a:rPr dirty="0"/>
+              <a:t> Mann–Whitney U, </a:t>
+            </a:r>
+            <a:r>
+              <a:rPr dirty="0" err="1"/>
+              <a:t>ikiden</a:t>
+            </a:r>
+            <a:r>
+              <a:rPr dirty="0"/>
+              <a:t> </a:t>
+            </a:r>
+            <a:r>
+              <a:rPr dirty="0" err="1"/>
+              <a:t>fazla</a:t>
+            </a:r>
+            <a:r>
+              <a:rPr dirty="0"/>
+              <a:t> </a:t>
+            </a:r>
+            <a:r>
+              <a:rPr dirty="0" err="1"/>
+              <a:t>grup</a:t>
+            </a:r>
+            <a:r>
+              <a:rPr dirty="0"/>
+              <a:t> </a:t>
+            </a:r>
+            <a:r>
+              <a:rPr dirty="0" err="1"/>
+              <a:t>karşılaştırmaları</a:t>
+            </a:r>
+            <a:r>
+              <a:rPr dirty="0"/>
+              <a:t> Kruskal–Wallis </a:t>
+            </a:r>
+            <a:r>
+              <a:rPr dirty="0" err="1"/>
+              <a:t>testiyle</a:t>
+            </a:r>
+            <a:r>
+              <a:rPr dirty="0"/>
+              <a:t> </a:t>
+            </a:r>
+            <a:r>
+              <a:rPr dirty="0" err="1"/>
+              <a:t>yapılmıştır</a:t>
+            </a:r>
+            <a:r>
+              <a:rPr dirty="0"/>
+              <a:t>. Post-hoc </a:t>
+            </a:r>
+            <a:r>
+              <a:rPr dirty="0" err="1"/>
+              <a:t>karşılaştırmalarda</a:t>
+            </a:r>
+            <a:r>
+              <a:rPr dirty="0"/>
+              <a:t> Duncan </a:t>
+            </a:r>
+            <a:r>
+              <a:rPr dirty="0" err="1"/>
+              <a:t>testi</a:t>
+            </a:r>
+            <a:r>
+              <a:rPr dirty="0"/>
+              <a:t> </a:t>
+            </a:r>
+            <a:r>
+              <a:rPr dirty="0" err="1"/>
+              <a:t>kullanılmıştır</a:t>
+            </a:r>
+            <a:r>
+              <a:rPr dirty="0"/>
+              <a:t>.</a:t>
+            </a:r>
+          </a:p>
+          <a:p>
+            <a:r>
+              <a:rPr dirty="0" err="1"/>
+              <a:t>Tedavi</a:t>
+            </a:r>
+            <a:r>
+              <a:rPr dirty="0"/>
+              <a:t> </a:t>
+            </a:r>
+            <a:r>
+              <a:rPr dirty="0" err="1"/>
+              <a:t>yöntemlerinin</a:t>
+            </a:r>
+            <a:r>
+              <a:rPr dirty="0"/>
+              <a:t> </a:t>
+            </a:r>
+            <a:r>
+              <a:rPr dirty="0" err="1"/>
+              <a:t>bırakma</a:t>
+            </a:r>
+            <a:r>
+              <a:rPr dirty="0"/>
+              <a:t> </a:t>
+            </a:r>
+            <a:r>
+              <a:rPr dirty="0" err="1"/>
+              <a:t>üzerindeki</a:t>
+            </a:r>
+            <a:r>
+              <a:rPr dirty="0"/>
+              <a:t> </a:t>
+            </a:r>
+            <a:r>
+              <a:rPr dirty="0" err="1"/>
+              <a:t>etkisi</a:t>
+            </a:r>
+            <a:r>
+              <a:rPr dirty="0"/>
+              <a:t> </a:t>
+            </a:r>
+            <a:r>
+              <a:rPr dirty="0" err="1"/>
+              <a:t>ikili</a:t>
+            </a:r>
+            <a:r>
+              <a:rPr dirty="0"/>
+              <a:t> </a:t>
+            </a:r>
+            <a:r>
+              <a:rPr dirty="0" err="1"/>
+              <a:t>lojistik</a:t>
+            </a:r>
+            <a:r>
+              <a:rPr dirty="0"/>
+              <a:t> </a:t>
+            </a:r>
+            <a:r>
+              <a:rPr dirty="0" err="1"/>
+              <a:t>regresyonla</a:t>
+            </a:r>
+            <a:r>
+              <a:rPr dirty="0"/>
+              <a:t> </a:t>
+            </a:r>
+            <a:r>
+              <a:rPr dirty="0" err="1"/>
+              <a:t>değerlendirilmiş</a:t>
+            </a:r>
+            <a:r>
+              <a:rPr dirty="0"/>
+              <a:t> </a:t>
+            </a:r>
+            <a:r>
+              <a:rPr dirty="0" err="1"/>
+              <a:t>ve</a:t>
+            </a:r>
+            <a:r>
+              <a:rPr dirty="0"/>
+              <a:t> Bonferroni </a:t>
+            </a:r>
+            <a:r>
+              <a:rPr dirty="0" err="1"/>
+              <a:t>düzeltmesi</a:t>
+            </a:r>
+            <a:r>
+              <a:rPr dirty="0"/>
+              <a:t> </a:t>
+            </a:r>
+            <a:r>
+              <a:rPr dirty="0" err="1"/>
+              <a:t>uygulanmıştır</a:t>
+            </a:r>
+            <a:r>
+              <a:rPr dirty="0"/>
+              <a:t>.</a:t>
             </a:r>
           </a:p>
         </p:txBody>
@@ -1037,7 +1312,7 @@
             </a:r>
             <a:r>
               <a:rPr lang="tr-TR" dirty="0"/>
-              <a:t>0,9u</a:t>
+              <a:t>09u</a:t>
             </a:r>
             <a:r>
               <a:rPr dirty="0"/>
@@ -3088,8 +3363,12 @@
           <a:lstStyle/>
           <a:p>
             <a:r>
+              <a:rPr lang="tr-TR" dirty="0" err="1"/>
+              <a:t>Burda</a:t>
+            </a:r>
+            <a:r>
               <a:rPr lang="tr-TR" dirty="0"/>
-              <a:t>Bu tabloda Sigara içme ve tedaviye ilişkin belirli parametreler sigara bırakma durumu ile karşılaştırılmış </a:t>
+              <a:t> da Sigara içme ve tedaviye ilişkin belirli parametreler sigara bırakma durumu ile karşılaştırılmış </a:t>
             </a:r>
             <a:r>
               <a:rPr dirty="0"/>
@@ -4335,7 +4614,7 @@
           <a:p>
             <a:r>
               <a:rPr lang="tr-TR" dirty="0"/>
-              <a:t>makalenin ilk sayfasını görüyorsunuz. Makale Türkiye Aile Hekimleri Uzmanlık Derneği'nin yayın organı olan </a:t>
+              <a:t>makalenin ilk sayfasını görüyorsunuz. Makale </a:t>
             </a:r>
             <a:r>
               <a:rPr lang="tr-TR" dirty="0" err="1"/>
@@ -8232,7 +8511,7 @@
           </a:prstGeom>
           <a:extLst>
             <a:ext uri="{C572A759-6A51-4108-AA02-DFA0A04FC94B}">
-              <ma14:wrappingTextBoxFlag xmlns="" xmlns:ma14="http://schemas.microsoft.com/office/mac/drawingml/2011/main" val="0"/>
+              <ma14:wrappingTextBoxFlag xmlns:ma14="http://schemas.microsoft.com/office/mac/drawingml/2011/main" xmlns="" val="0"/>
             </a:ext>
           </a:extLst>
         </p:spPr>
@@ -8351,7 +8630,7 @@
           </a:prstGeom>
           <a:extLst>
             <a:ext uri="{C572A759-6A51-4108-AA02-DFA0A04FC94B}">
-              <ma14:wrappingTextBoxFlag xmlns="" xmlns:ma14="http://schemas.microsoft.com/office/mac/drawingml/2011/main" val="0"/>
+              <ma14:wrappingTextBoxFlag xmlns:ma14="http://schemas.microsoft.com/office/mac/drawingml/2011/main" xmlns="" val="0"/>
             </a:ext>
           </a:extLst>
         </p:spPr>
@@ -8470,7 +8749,7 @@
           </a:prstGeom>
           <a:extLst>
             <a:ext uri="{C572A759-6A51-4108-AA02-DFA0A04FC94B}">
-              <ma14:wrappingTextBoxFlag xmlns="" xmlns:ma14="http://schemas.microsoft.com/office/mac/drawingml/2011/main" val="0"/>
+              <ma14:wrappingTextBoxFlag xmlns:ma14="http://schemas.microsoft.com/office/mac/drawingml/2011/main" xmlns="" val="0"/>
             </a:ext>
           </a:extLst>
         </p:spPr>
@@ -8545,7 +8824,7 @@
           </a:prstGeom>
           <a:extLst>
             <a:ext uri="{C572A759-6A51-4108-AA02-DFA0A04FC94B}">
-              <ma14:wrappingTextBoxFlag xmlns="" xmlns:ma14="http://schemas.microsoft.com/office/mac/drawingml/2011/main" val="0"/>
+              <ma14:wrappingTextBoxFlag xmlns:ma14="http://schemas.microsoft.com/office/mac/drawingml/2011/main" xmlns="" val="0"/>
             </a:ext>
           </a:extLst>
         </p:spPr>
@@ -9073,7 +9352,7 @@
           </a:prstGeom>
           <a:extLst>
             <a:ext uri="{C572A759-6A51-4108-AA02-DFA0A04FC94B}">
-              <ma14:wrappingTextBoxFlag xmlns="" xmlns:ma14="http://schemas.microsoft.com/office/mac/drawingml/2011/main" val="0"/>
+              <ma14:wrappingTextBoxFlag xmlns:ma14="http://schemas.microsoft.com/office/mac/drawingml/2011/main" xmlns="" val="0"/>
             </a:ext>
           </a:extLst>
         </p:spPr>
@@ -10128,7 +10407,7 @@
           </a:prstGeom>
           <a:extLst>
             <a:ext uri="{C572A759-6A51-4108-AA02-DFA0A04FC94B}">
-              <ma14:wrappingTextBoxFlag xmlns="" xmlns:ma14="http://schemas.microsoft.com/office/mac/drawingml/2011/main" val="0"/>
+              <ma14:wrappingTextBoxFlag xmlns:ma14="http://schemas.microsoft.com/office/mac/drawingml/2011/main" xmlns="" val="0"/>
             </a:ext>
           </a:extLst>
         </p:spPr>
@@ -10896,7 +11175,7 @@
           </a:prstGeom>
           <a:extLst>
             <a:ext uri="{C572A759-6A51-4108-AA02-DFA0A04FC94B}">
-              <ma14:wrappingTextBoxFlag xmlns="" xmlns:ma14="http://schemas.microsoft.com/office/mac/drawingml/2011/main" val="0"/>
+              <ma14:wrappingTextBoxFlag xmlns:ma14="http://schemas.microsoft.com/office/mac/drawingml/2011/main" xmlns="" val="0"/>
             </a:ext>
           </a:extLst>
         </p:spPr>
@@ -11654,7 +11933,7 @@
           </a:prstGeom>
           <a:extLst>
             <a:ext uri="{C572A759-6A51-4108-AA02-DFA0A04FC94B}">
-              <ma14:wrappingTextBoxFlag xmlns="" xmlns:ma14="http://schemas.microsoft.com/office/mac/drawingml/2011/main" val="0"/>
+              <ma14:wrappingTextBoxFlag xmlns:ma14="http://schemas.microsoft.com/office/mac/drawingml/2011/main" xmlns="" val="0"/>
             </a:ext>
           </a:extLst>
         </p:spPr>
@@ -12031,7 +12310,7 @@
           </a:prstGeom>
           <a:extLst>
             <a:ext uri="{C572A759-6A51-4108-AA02-DFA0A04FC94B}">
-              <ma14:wrappingTextBoxFlag xmlns="" xmlns:ma14="http://schemas.microsoft.com/office/mac/drawingml/2011/main" val="0"/>
+              <ma14:wrappingTextBoxFlag xmlns:ma14="http://schemas.microsoft.com/office/mac/drawingml/2011/main" xmlns="" val="0"/>
             </a:ext>
           </a:extLst>
         </p:spPr>
@@ -12310,7 +12589,7 @@
           </a:prstGeom>
           <a:extLst>
             <a:ext uri="{C572A759-6A51-4108-AA02-DFA0A04FC94B}">
-              <ma14:wrappingTextBoxFlag xmlns="" xmlns:ma14="http://schemas.microsoft.com/office/mac/drawingml/2011/main" val="0"/>
+              <ma14:wrappingTextBoxFlag xmlns:ma14="http://schemas.microsoft.com/office/mac/drawingml/2011/main" xmlns="" val="0"/>
             </a:ext>
           </a:extLst>
         </p:spPr>
@@ -12601,7 +12880,7 @@
           </a:prstGeom>
           <a:extLst>
             <a:ext uri="{C572A759-6A51-4108-AA02-DFA0A04FC94B}">
-              <ma14:wrappingTextBoxFlag xmlns="" xmlns:ma14="http://schemas.microsoft.com/office/mac/drawingml/2011/main" val="0"/>
+              <ma14:wrappingTextBoxFlag xmlns:ma14="http://schemas.microsoft.com/office/mac/drawingml/2011/main" xmlns="" val="0"/>
             </a:ext>
           </a:extLst>
         </p:spPr>
@@ -12880,7 +13159,7 @@
           </a:prstGeom>
           <a:extLst>
             <a:ext uri="{C572A759-6A51-4108-AA02-DFA0A04FC94B}">
-              <ma14:wrappingTextBoxFlag xmlns="" xmlns:ma14="http://schemas.microsoft.com/office/mac/drawingml/2011/main" val="0"/>
+              <ma14:wrappingTextBoxFlag xmlns:ma14="http://schemas.microsoft.com/office/mac/drawingml/2011/main" xmlns="" val="0"/>
             </a:ext>
           </a:extLst>
         </p:spPr>
@@ -13320,7 +13599,7 @@
           </a:prstGeom>
           <a:extLst>
             <a:ext uri="{C572A759-6A51-4108-AA02-DFA0A04FC94B}">
-              <ma14:wrappingTextBoxFlag xmlns="" xmlns:ma14="http://schemas.microsoft.com/office/mac/drawingml/2011/main" val="0"/>
+              <ma14:wrappingTextBoxFlag xmlns:ma14="http://schemas.microsoft.com/office/mac/drawingml/2011/main" xmlns="" val="0"/>
             </a:ext>
           </a:extLst>
         </p:spPr>
@@ -13763,7 +14042,7 @@
           </a:prstGeom>
           <a:extLst>
             <a:ext uri="{C572A759-6A51-4108-AA02-DFA0A04FC94B}">
-              <ma14:wrappingTextBoxFlag xmlns="" xmlns:ma14="http://schemas.microsoft.com/office/mac/drawingml/2011/main" val="0"/>
+              <ma14:wrappingTextBoxFlag xmlns:ma14="http://schemas.microsoft.com/office/mac/drawingml/2011/main" xmlns="" val="0"/>
             </a:ext>
           </a:extLst>
         </p:spPr>
@@ -14071,7 +14350,7 @@
           </a:prstGeom>
           <a:extLst>
             <a:ext uri="{C572A759-6A51-4108-AA02-DFA0A04FC94B}">
-              <ma14:wrappingTextBoxFlag xmlns="" xmlns:ma14="http://schemas.microsoft.com/office/mac/drawingml/2011/main" val="0"/>
+              <ma14:wrappingTextBoxFlag xmlns:ma14="http://schemas.microsoft.com/office/mac/drawingml/2011/main" xmlns="" val="0"/>
             </a:ext>
           </a:extLst>
         </p:spPr>
@@ -14841,7 +15120,7 @@
           </a:prstGeom>
           <a:extLst>
             <a:ext uri="{C572A759-6A51-4108-AA02-DFA0A04FC94B}">
-              <ma14:wrappingTextBoxFlag xmlns="" xmlns:ma14="http://schemas.microsoft.com/office/mac/drawingml/2011/main" val="0"/>
+              <ma14:wrappingTextBoxFlag xmlns:ma14="http://schemas.microsoft.com/office/mac/drawingml/2011/main" xmlns="" val="0"/>
             </a:ext>
           </a:extLst>
         </p:spPr>
@@ -15487,7 +15766,7 @@
           </a:prstGeom>
           <a:extLst>
             <a:ext uri="{C572A759-6A51-4108-AA02-DFA0A04FC94B}">
-              <ma14:wrappingTextBoxFlag xmlns="" xmlns:ma14="http://schemas.microsoft.com/office/mac/drawingml/2011/main" val="0"/>
+              <ma14:wrappingTextBoxFlag xmlns:ma14="http://schemas.microsoft.com/office/mac/drawingml/2011/main" xmlns="" val="0"/>
             </a:ext>
           </a:extLst>
         </p:spPr>
@@ -15955,7 +16234,7 @@
           </a:prstGeom>
           <a:extLst>
             <a:ext uri="{C572A759-6A51-4108-AA02-DFA0A04FC94B}">
-              <ma14:wrappingTextBoxFlag xmlns="" xmlns:ma14="http://schemas.microsoft.com/office/mac/drawingml/2011/main" val="0"/>
+              <ma14:wrappingTextBoxFlag xmlns:ma14="http://schemas.microsoft.com/office/mac/drawingml/2011/main" xmlns="" val="0"/>
             </a:ext>
           </a:extLst>
         </p:spPr>
@@ -16398,7 +16677,7 @@
           </a:prstGeom>
           <a:extLst>
             <a:ext uri="{C572A759-6A51-4108-AA02-DFA0A04FC94B}">
-              <ma14:wrappingTextBoxFlag xmlns="" xmlns:ma14="http://schemas.microsoft.com/office/mac/drawingml/2011/main" val="0"/>
+              <ma14:wrappingTextBoxFlag xmlns:ma14="http://schemas.microsoft.com/office/mac/drawingml/2011/main" xmlns="" val="0"/>
             </a:ext>
           </a:extLst>
         </p:spPr>
@@ -16968,7 +17247,7 @@
           </a:prstGeom>
           <a:extLst>
             <a:ext uri="{C572A759-6A51-4108-AA02-DFA0A04FC94B}">
-              <ma14:wrappingTextBoxFlag xmlns="" xmlns:ma14="http://schemas.microsoft.com/office/mac/drawingml/2011/main" val="0"/>
+              <ma14:wrappingTextBoxFlag xmlns:ma14="http://schemas.microsoft.com/office/mac/drawingml/2011/main" xmlns="" val="0"/>
             </a:ext>
           </a:extLst>
         </p:spPr>
@@ -17426,7 +17705,7 @@
           </a:prstGeom>
           <a:extLst>
             <a:ext uri="{C572A759-6A51-4108-AA02-DFA0A04FC94B}">
-              <ma14:wrappingTextBoxFlag xmlns="" xmlns:ma14="http://schemas.microsoft.com/office/mac/drawingml/2011/main" val="0"/>
+              <ma14:wrappingTextBoxFlag xmlns:ma14="http://schemas.microsoft.com/office/mac/drawingml/2011/main" xmlns="" val="0"/>
             </a:ext>
           </a:extLst>
         </p:spPr>
@@ -17696,7 +17975,7 @@
           </a:prstGeom>
           <a:extLst>
             <a:ext uri="{C572A759-6A51-4108-AA02-DFA0A04FC94B}">
-              <ma14:wrappingTextBoxFlag xmlns="" xmlns:ma14="http://schemas.microsoft.com/office/mac/drawingml/2011/main" val="0"/>
+              <ma14:wrappingTextBoxFlag xmlns:ma14="http://schemas.microsoft.com/office/mac/drawingml/2011/main" xmlns="" val="0"/>
             </a:ext>
           </a:extLst>
         </p:spPr>
@@ -18504,7 +18783,7 @@
           </a:prstGeom>
           <a:extLst>
             <a:ext uri="{C572A759-6A51-4108-AA02-DFA0A04FC94B}">
-              <ma14:wrappingTextBoxFlag xmlns="" xmlns:ma14="http://schemas.microsoft.com/office/mac/drawingml/2011/main" val="0"/>
+              <ma14:wrappingTextBoxFlag xmlns:ma14="http://schemas.microsoft.com/office/mac/drawingml/2011/main" xmlns="" val="0"/>
             </a:ext>
           </a:extLst>
         </p:spPr>
@@ -19206,7 +19485,7 @@
           </a:prstGeom>
           <a:extLst>
             <a:ext uri="{C572A759-6A51-4108-AA02-DFA0A04FC94B}">
-              <ma14:wrappingTextBoxFlag xmlns="" xmlns:ma14="http://schemas.microsoft.com/office/mac/drawingml/2011/main" val="0"/>
+              <ma14:wrappingTextBoxFlag xmlns:ma14="http://schemas.microsoft.com/office/mac/drawingml/2011/main" xmlns="" val="0"/>
             </a:ext>
           </a:extLst>
         </p:spPr>
@@ -19874,7 +20153,7 @@
           </a:prstGeom>
           <a:extLst>
             <a:ext uri="{C572A759-6A51-4108-AA02-DFA0A04FC94B}">
-              <ma14:wrappingTextBoxFlag xmlns="" xmlns:ma14="http://schemas.microsoft.com/office/mac/drawingml/2011/main" val="0"/>
+              <ma14:wrappingTextBoxFlag xmlns:ma14="http://schemas.microsoft.com/office/mac/drawingml/2011/main" xmlns="" val="0"/>
             </a:ext>
           </a:extLst>
         </p:spPr>
@@ -20118,7 +20397,7 @@
           </a:prstGeom>
           <a:extLst>
             <a:ext uri="{C572A759-6A51-4108-AA02-DFA0A04FC94B}">
-              <ma14:wrappingTextBoxFlag xmlns="" xmlns:ma14="http://schemas.microsoft.com/office/mac/drawingml/2011/main" val="0"/>
+              <ma14:wrappingTextBoxFlag xmlns:ma14="http://schemas.microsoft.com/office/mac/drawingml/2011/main" xmlns="" val="0"/>
             </a:ext>
           </a:extLst>
         </p:spPr>
@@ -20782,7 +21061,7 @@
           </a:prstGeom>
           <a:extLst>
             <a:ext uri="{C572A759-6A51-4108-AA02-DFA0A04FC94B}">
-              <ma14:wrappingTextBoxFlag xmlns="" xmlns:ma14="http://schemas.microsoft.com/office/mac/drawingml/2011/main" val="0"/>
+              <ma14:wrappingTextBoxFlag xmlns:ma14="http://schemas.microsoft.com/office/mac/drawingml/2011/main" xmlns="" val="0"/>
             </a:ext>
           </a:extLst>
         </p:spPr>
@@ -21603,7 +21882,7 @@
           </a:prstGeom>
           <a:extLst>
             <a:ext uri="{C572A759-6A51-4108-AA02-DFA0A04FC94B}">
-              <ma14:wrappingTextBoxFlag xmlns="" xmlns:ma14="http://schemas.microsoft.com/office/mac/drawingml/2011/main" val="0"/>
+              <ma14:wrappingTextBoxFlag xmlns:ma14="http://schemas.microsoft.com/office/mac/drawingml/2011/main" xmlns="" val="0"/>
             </a:ext>
           </a:extLst>
         </p:spPr>
@@ -22215,7 +22494,7 @@
           </a:prstGeom>
           <a:extLst>
             <a:ext uri="{C572A759-6A51-4108-AA02-DFA0A04FC94B}">
-              <ma14:wrappingTextBoxFlag xmlns="" xmlns:ma14="http://schemas.microsoft.com/office/mac/drawingml/2011/main" val="0"/>
+              <ma14:wrappingTextBoxFlag xmlns:ma14="http://schemas.microsoft.com/office/mac/drawingml/2011/main" xmlns="" val="0"/>
             </a:ext>
           </a:extLst>
         </p:spPr>

</xml_diff>